<commit_message>
Strikethrough & Url orrection
</commit_message>
<xml_diff>
--- a/dochtml-demo.pptx
+++ b/dochtml-demo.pptx
@@ -13,9 +13,10 @@
     <p:sldId id="261" r:id="rId7"/>
     <p:sldId id="262" r:id="rId8"/>
     <p:sldId id="263" r:id="rId9"/>
+    <p:sldId id="264" r:id="rId10"/>
   </p:sldIdLst>
   <p:notesMasterIdLst>
-    <p:notesMasterId r:id="rId10"/>
+    <p:notesMasterId r:id="rId11"/>
   </p:notesMasterIdLst>
   <p:sldSz cx="9144000" cy="5143500"/>
   <p:notesSz cx="5143500" cy="9144000"/>
@@ -1149,6 +1150,94 @@
             <a:fld id="{F7021451-1387-4CA6-816F-3879F97B5CBC}" type="slidenum">
               <a:rPr lang="en-US"/>
               <a:t>8</a:t>
+            </a:fld>
+            <a:endParaRPr lang="en-US"/>
+          </a:p>
+        </p:txBody>
+      </p:sp>
+    </p:spTree>
+    <p:extLst>
+      <p:ext uri="{BB962C8B-B14F-4D97-AF65-F5344CB8AC3E}">
+        <p14:creationId xmlns:p14="http://schemas.microsoft.com/office/powerpoint/2010/main" val="1024086991"/>
+      </p:ext>
+    </p:extLst>
+  </p:cSld>
+  <p:clrMapOvr>
+    <a:masterClrMapping/>
+  </p:clrMapOvr>
+</p:notes>
+</file>
+
+<file path=ppt/notesSlides/notesSlide9.xml><?xml version="1.0" encoding="utf-8"?>
+<p:notes xmlns:a="http://schemas.openxmlformats.org/drawingml/2006/main" xmlns:r="http://schemas.openxmlformats.org/officeDocument/2006/relationships" xmlns:p="http://schemas.openxmlformats.org/presentationml/2006/main">
+  <p:cSld>
+    <p:spTree>
+      <p:nvGrpSpPr>
+        <p:cNvPr id="1" name=""/>
+        <p:cNvGrpSpPr/>
+        <p:nvPr/>
+      </p:nvGrpSpPr>
+      <p:grpSpPr>
+        <a:xfrm>
+          <a:off x="0" y="0"/>
+          <a:ext cx="0" cy="0"/>
+          <a:chOff x="0" y="0"/>
+          <a:chExt cx="0" cy="0"/>
+        </a:xfrm>
+      </p:grpSpPr>
+      <p:sp>
+        <p:nvSpPr>
+          <p:cNvPr id="2" name="Slide Image Placeholder 1"/>
+          <p:cNvSpPr>
+            <a:spLocks noGrp="1" noRot="1" noChangeAspect="1"/>
+          </p:cNvSpPr>
+          <p:nvPr>
+            <p:ph type="sldImg"/>
+          </p:nvPr>
+        </p:nvSpPr>
+        <p:spPr/>
+      </p:sp>
+      <p:sp>
+        <p:nvSpPr>
+          <p:cNvPr id="3" name="Notes Placeholder 2"/>
+          <p:cNvSpPr>
+            <a:spLocks noGrp="1"/>
+          </p:cNvSpPr>
+          <p:nvPr>
+            <p:ph type="body" idx="1"/>
+          </p:nvPr>
+        </p:nvSpPr>
+        <p:spPr/>
+        <p:txBody>
+          <a:bodyPr/>
+          <a:lstStyle/>
+          <a:p>
+            <a:r>
+              <a:rPr lang="en-US" dirty="0"/>
+              <a:t/>
+            </a:r>
+            <a:endParaRPr lang="en-US" dirty="0"/>
+          </a:p>
+        </p:txBody>
+      </p:sp>
+      <p:sp>
+        <p:nvSpPr>
+          <p:cNvPr id="4" name="Slide Number Placeholder 3"/>
+          <p:cNvSpPr>
+            <a:spLocks noGrp="1"/>
+          </p:cNvSpPr>
+          <p:nvPr>
+            <p:ph type="sldNum" sz="quarter" idx="10"/>
+          </p:nvPr>
+        </p:nvSpPr>
+        <p:spPr/>
+        <p:txBody>
+          <a:bodyPr/>
+          <a:lstStyle/>
+          <a:p>
+            <a:fld id="{F7021451-1387-4CA6-816F-3879F97B5CBC}" type="slidenum">
+              <a:rPr lang="en-US"/>
+              <a:t>9</a:t>
             </a:fld>
             <a:endParaRPr lang="en-US"/>
           </a:p>
@@ -2439,11 +2528,11 @@
         <p:spPr>
           <a:xfrm>
             <a:off x="4754880" y="1645920"/>
-            <a:ext cx="3931920" cy="365760"/>
+            <a:ext cx="3931920" cy="329184"/>
           </a:xfrm>
           <a:prstGeom prst="roundRect">
             <a:avLst>
-              <a:gd name="adj" fmla="val 15000"/>
+              <a:gd name="adj" fmla="val 16667"/>
             </a:avLst>
           </a:prstGeom>
           <a:solidFill>
@@ -2466,23 +2555,23 @@
         <p:spPr>
           <a:xfrm>
             <a:off x="4846320" y="1645920"/>
-            <a:ext cx="3749040" cy="365760"/>
-          </a:xfrm>
-          <a:prstGeom prst="rect">
-            <a:avLst/>
-          </a:prstGeom>
-          <a:noFill/>
-          <a:ln/>
-        </p:spPr>
-        <p:txBody>
-          <a:bodyPr wrap="square" lIns="0" tIns="0" rIns="0" bIns="0" rtlCol="0" anchor="ctr"/>
-          <a:lstStyle/>
-          <a:p>
-            <a:pPr indent="0" marL="0">
-              <a:buNone/>
-            </a:pPr>
-            <a:r>
-              <a:rPr lang="en-US" sz="1100" dirty="0">
+            <a:ext cx="3749040" cy="329184"/>
+          </a:xfrm>
+          <a:prstGeom prst="rect">
+            <a:avLst/>
+          </a:prstGeom>
+          <a:noFill/>
+          <a:ln/>
+        </p:spPr>
+        <p:txBody>
+          <a:bodyPr wrap="square" lIns="0" tIns="0" rIns="0" bIns="0" rtlCol="0" anchor="ctr"/>
+          <a:lstStyle/>
+          <a:p>
+            <a:pPr indent="0" marL="0">
+              <a:buNone/>
+            </a:pPr>
+            <a:r>
+              <a:rPr lang="en-US" sz="1000" dirty="0">
                 <a:solidFill>
                   <a:srgbClr val="2D6A4F"/>
                 </a:solidFill>
@@ -2490,9 +2579,9 @@
                 <a:ea typeface="Calibri" pitchFamily="34" charset="-122"/>
                 <a:cs typeface="Calibri" pitchFamily="34" charset="-120"/>
               </a:rPr>
-              <a:t>✓  11 automatic transformation rules</a:t>
-            </a:r>
-            <a:endParaRPr lang="en-US" sz="1100" dirty="0"/>
+              <a:t>✓  14 automatic transformation rules</a:t>
+            </a:r>
+            <a:endParaRPr lang="en-US" sz="1000" dirty="0"/>
           </a:p>
         </p:txBody>
       </p:sp>
@@ -2504,12 +2593,12 @@
         </p:nvSpPr>
         <p:spPr>
           <a:xfrm>
-            <a:off x="4754880" y="2093976"/>
-            <a:ext cx="3931920" cy="365760"/>
+            <a:off x="4754880" y="2029968"/>
+            <a:ext cx="3931920" cy="329184"/>
           </a:xfrm>
           <a:prstGeom prst="roundRect">
             <a:avLst>
-              <a:gd name="adj" fmla="val 15000"/>
+              <a:gd name="adj" fmla="val 16667"/>
             </a:avLst>
           </a:prstGeom>
           <a:solidFill>
@@ -2531,24 +2620,24 @@
         </p:nvSpPr>
         <p:spPr>
           <a:xfrm>
-            <a:off x="4846320" y="2093976"/>
-            <a:ext cx="3749040" cy="365760"/>
-          </a:xfrm>
-          <a:prstGeom prst="rect">
-            <a:avLst/>
-          </a:prstGeom>
-          <a:noFill/>
-          <a:ln/>
-        </p:spPr>
-        <p:txBody>
-          <a:bodyPr wrap="square" lIns="0" tIns="0" rIns="0" bIns="0" rtlCol="0" anchor="ctr"/>
-          <a:lstStyle/>
-          <a:p>
-            <a:pPr indent="0" marL="0">
-              <a:buNone/>
-            </a:pPr>
-            <a:r>
-              <a:rPr lang="en-US" sz="1100" dirty="0">
+            <a:off x="4846320" y="2029968"/>
+            <a:ext cx="3749040" cy="329184"/>
+          </a:xfrm>
+          <a:prstGeom prst="rect">
+            <a:avLst/>
+          </a:prstGeom>
+          <a:noFill/>
+          <a:ln/>
+        </p:spPr>
+        <p:txBody>
+          <a:bodyPr wrap="square" lIns="0" tIns="0" rIns="0" bIns="0" rtlCol="0" anchor="ctr"/>
+          <a:lstStyle/>
+          <a:p>
+            <a:pPr indent="0" marL="0">
+              <a:buNone/>
+            </a:pPr>
+            <a:r>
+              <a:rPr lang="en-US" sz="1000" dirty="0">
                 <a:solidFill>
                   <a:srgbClr val="2D6A4F"/>
                 </a:solidFill>
@@ -2558,7 +2647,7 @@
               </a:rPr>
               <a:t>✓  Strips all inline styles &amp; MSO junk</a:t>
             </a:r>
-            <a:endParaRPr lang="en-US" sz="1100" dirty="0"/>
+            <a:endParaRPr lang="en-US" sz="1000" dirty="0"/>
           </a:p>
         </p:txBody>
       </p:sp>
@@ -2570,12 +2659,12 @@
         </p:nvSpPr>
         <p:spPr>
           <a:xfrm>
-            <a:off x="4754880" y="2542032"/>
-            <a:ext cx="3931920" cy="365760"/>
+            <a:off x="4754880" y="2414016"/>
+            <a:ext cx="3931920" cy="329184"/>
           </a:xfrm>
           <a:prstGeom prst="roundRect">
             <a:avLst>
-              <a:gd name="adj" fmla="val 15000"/>
+              <a:gd name="adj" fmla="val 16667"/>
             </a:avLst>
           </a:prstGeom>
           <a:solidFill>
@@ -2597,24 +2686,24 @@
         </p:nvSpPr>
         <p:spPr>
           <a:xfrm>
-            <a:off x="4846320" y="2542032"/>
-            <a:ext cx="3749040" cy="365760"/>
-          </a:xfrm>
-          <a:prstGeom prst="rect">
-            <a:avLst/>
-          </a:prstGeom>
-          <a:noFill/>
-          <a:ln/>
-        </p:spPr>
-        <p:txBody>
-          <a:bodyPr wrap="square" lIns="0" tIns="0" rIns="0" bIns="0" rtlCol="0" anchor="ctr"/>
-          <a:lstStyle/>
-          <a:p>
-            <a:pPr indent="0" marL="0">
-              <a:buNone/>
-            </a:pPr>
-            <a:r>
-              <a:rPr lang="en-US" sz="1100" dirty="0">
+            <a:off x="4846320" y="2414016"/>
+            <a:ext cx="3749040" cy="329184"/>
+          </a:xfrm>
+          <a:prstGeom prst="rect">
+            <a:avLst/>
+          </a:prstGeom>
+          <a:noFill/>
+          <a:ln/>
+        </p:spPr>
+        <p:txBody>
+          <a:bodyPr wrap="square" lIns="0" tIns="0" rIns="0" bIns="0" rtlCol="0" anchor="ctr"/>
+          <a:lstStyle/>
+          <a:p>
+            <a:pPr indent="0" marL="0">
+              <a:buNone/>
+            </a:pPr>
+            <a:r>
+              <a:rPr lang="en-US" sz="1000" dirty="0">
                 <a:solidFill>
                   <a:srgbClr val="2D6A4F"/>
                 </a:solidFill>
@@ -2624,7 +2713,7 @@
               </a:rPr>
               <a:t>✓  Bold rows → &lt;th scope="col"&gt; detection</a:t>
             </a:r>
-            <a:endParaRPr lang="en-US" sz="1100" dirty="0"/>
+            <a:endParaRPr lang="en-US" sz="1000" dirty="0"/>
           </a:p>
         </p:txBody>
       </p:sp>
@@ -2636,12 +2725,12 @@
         </p:nvSpPr>
         <p:spPr>
           <a:xfrm>
-            <a:off x="4754880" y="2990088"/>
-            <a:ext cx="3931920" cy="365760"/>
+            <a:off x="4754880" y="2798064"/>
+            <a:ext cx="3931920" cy="329184"/>
           </a:xfrm>
           <a:prstGeom prst="roundRect">
             <a:avLst>
-              <a:gd name="adj" fmla="val 15000"/>
+              <a:gd name="adj" fmla="val 16667"/>
             </a:avLst>
           </a:prstGeom>
           <a:solidFill>
@@ -2663,24 +2752,24 @@
         </p:nvSpPr>
         <p:spPr>
           <a:xfrm>
-            <a:off x="4846320" y="2990088"/>
-            <a:ext cx="3749040" cy="365760"/>
-          </a:xfrm>
-          <a:prstGeom prst="rect">
-            <a:avLst/>
-          </a:prstGeom>
-          <a:noFill/>
-          <a:ln/>
-        </p:spPr>
-        <p:txBody>
-          <a:bodyPr wrap="square" lIns="0" tIns="0" rIns="0" bIns="0" rtlCol="0" anchor="ctr"/>
-          <a:lstStyle/>
-          <a:p>
-            <a:pPr indent="0" marL="0">
-              <a:buNone/>
-            </a:pPr>
-            <a:r>
-              <a:rPr lang="en-US" sz="1100" dirty="0">
+            <a:off x="4846320" y="2798064"/>
+            <a:ext cx="3749040" cy="329184"/>
+          </a:xfrm>
+          <a:prstGeom prst="rect">
+            <a:avLst/>
+          </a:prstGeom>
+          <a:noFill/>
+          <a:ln/>
+        </p:spPr>
+        <p:txBody>
+          <a:bodyPr wrap="square" lIns="0" tIns="0" rIns="0" bIns="0" rtlCol="0" anchor="ctr"/>
+          <a:lstStyle/>
+          <a:p>
+            <a:pPr indent="0" marL="0">
+              <a:buNone/>
+            </a:pPr>
+            <a:r>
+              <a:rPr lang="en-US" sz="1000" dirty="0">
                 <a:solidFill>
                   <a:srgbClr val="2D6A4F"/>
                 </a:solidFill>
@@ -2690,7 +2779,7 @@
               </a:rPr>
               <a:t>✓  Fax number exclusion from tel: links</a:t>
             </a:r>
-            <a:endParaRPr lang="en-US" sz="1100" dirty="0"/>
+            <a:endParaRPr lang="en-US" sz="1000" dirty="0"/>
           </a:p>
         </p:txBody>
       </p:sp>
@@ -2702,12 +2791,12 @@
         </p:nvSpPr>
         <p:spPr>
           <a:xfrm>
-            <a:off x="4754880" y="3438144"/>
-            <a:ext cx="3931920" cy="365760"/>
+            <a:off x="4754880" y="3182112"/>
+            <a:ext cx="3931920" cy="329184"/>
           </a:xfrm>
           <a:prstGeom prst="roundRect">
             <a:avLst>
-              <a:gd name="adj" fmla="val 15000"/>
+              <a:gd name="adj" fmla="val 16667"/>
             </a:avLst>
           </a:prstGeom>
           <a:solidFill>
@@ -2729,24 +2818,24 @@
         </p:nvSpPr>
         <p:spPr>
           <a:xfrm>
-            <a:off x="4846320" y="3438144"/>
-            <a:ext cx="3749040" cy="365760"/>
-          </a:xfrm>
-          <a:prstGeom prst="rect">
-            <a:avLst/>
-          </a:prstGeom>
-          <a:noFill/>
-          <a:ln/>
-        </p:spPr>
-        <p:txBody>
-          <a:bodyPr wrap="square" lIns="0" tIns="0" rIns="0" bIns="0" rtlCol="0" anchor="ctr"/>
-          <a:lstStyle/>
-          <a:p>
-            <a:pPr indent="0" marL="0">
-              <a:buNone/>
-            </a:pPr>
-            <a:r>
-              <a:rPr lang="en-US" sz="1100" dirty="0">
+            <a:off x="4846320" y="3182112"/>
+            <a:ext cx="3749040" cy="329184"/>
+          </a:xfrm>
+          <a:prstGeom prst="rect">
+            <a:avLst/>
+          </a:prstGeom>
+          <a:noFill/>
+          <a:ln/>
+        </p:spPr>
+        <p:txBody>
+          <a:bodyPr wrap="square" lIns="0" tIns="0" rIns="0" bIns="0" rtlCol="0" anchor="ctr"/>
+          <a:lstStyle/>
+          <a:p>
+            <a:pPr indent="0" marL="0">
+              <a:buNone/>
+            </a:pPr>
+            <a:r>
+              <a:rPr lang="en-US" sz="1000" dirty="0">
                 <a:solidFill>
                   <a:srgbClr val="2D6A4F"/>
                 </a:solidFill>
@@ -2754,9 +2843,9 @@
                 <a:ea typeface="Calibri" pitchFamily="34" charset="-122"/>
                 <a:cs typeface="Calibri" pitchFamily="34" charset="-120"/>
               </a:rPr>
-              <a:t>✓  Consecutive &lt;strong&gt; tag merging</a:t>
-            </a:r>
-            <a:endParaRPr lang="en-US" sz="1100" dirty="0"/>
+              <a:t>✓  Strikethrough text removed entirely</a:t>
+            </a:r>
+            <a:endParaRPr lang="en-US" sz="1000" dirty="0"/>
           </a:p>
         </p:txBody>
       </p:sp>
@@ -2768,12 +2857,12 @@
         </p:nvSpPr>
         <p:spPr>
           <a:xfrm>
-            <a:off x="4754880" y="3886200"/>
-            <a:ext cx="3931920" cy="365760"/>
+            <a:off x="4754880" y="3566160"/>
+            <a:ext cx="3931920" cy="329184"/>
           </a:xfrm>
           <a:prstGeom prst="roundRect">
             <a:avLst>
-              <a:gd name="adj" fmla="val 15000"/>
+              <a:gd name="adj" fmla="val 16667"/>
             </a:avLst>
           </a:prstGeom>
           <a:solidFill>
@@ -2795,24 +2884,24 @@
         </p:nvSpPr>
         <p:spPr>
           <a:xfrm>
-            <a:off x="4846320" y="3886200"/>
-            <a:ext cx="3749040" cy="365760"/>
-          </a:xfrm>
-          <a:prstGeom prst="rect">
-            <a:avLst/>
-          </a:prstGeom>
-          <a:noFill/>
-          <a:ln/>
-        </p:spPr>
-        <p:txBody>
-          <a:bodyPr wrap="square" lIns="0" tIns="0" rIns="0" bIns="0" rtlCol="0" anchor="ctr"/>
-          <a:lstStyle/>
-          <a:p>
-            <a:pPr indent="0" marL="0">
-              <a:buNone/>
-            </a:pPr>
-            <a:r>
-              <a:rPr lang="en-US" sz="1100" dirty="0">
+            <a:off x="4846320" y="3566160"/>
+            <a:ext cx="3749040" cy="329184"/>
+          </a:xfrm>
+          <a:prstGeom prst="rect">
+            <a:avLst/>
+          </a:prstGeom>
+          <a:noFill/>
+          <a:ln/>
+        </p:spPr>
+        <p:txBody>
+          <a:bodyPr wrap="square" lIns="0" tIns="0" rIns="0" bIns="0" rtlCol="0" anchor="ctr"/>
+          <a:lstStyle/>
+          <a:p>
+            <a:pPr indent="0" marL="0">
+              <a:buNone/>
+            </a:pPr>
+            <a:r>
+              <a:rPr lang="en-US" sz="1000" dirty="0">
                 <a:solidFill>
                   <a:srgbClr val="2D6A4F"/>
                 </a:solidFill>
@@ -2820,9 +2909,141 @@
                 <a:ea typeface="Calibri" pitchFamily="34" charset="-122"/>
                 <a:cs typeface="Calibri" pitchFamily="34" charset="-120"/>
               </a:rPr>
-              <a:t>✓  Identical rules for file &amp; editor paths</a:t>
-            </a:r>
-            <a:endParaRPr lang="en-US" sz="1100" dirty="0"/>
+              <a:t>✓  &lt;strong&gt; always wraps &lt;a&gt; links</a:t>
+            </a:r>
+            <a:endParaRPr lang="en-US" sz="1000" dirty="0"/>
+          </a:p>
+        </p:txBody>
+      </p:sp>
+      <p:sp>
+        <p:nvSpPr>
+          <p:cNvPr id="27" name="Shape 25"/>
+          <p:cNvSpPr/>
+          <p:nvPr/>
+        </p:nvSpPr>
+        <p:spPr>
+          <a:xfrm>
+            <a:off x="4754880" y="3950208"/>
+            <a:ext cx="3931920" cy="329184"/>
+          </a:xfrm>
+          <a:prstGeom prst="roundRect">
+            <a:avLst>
+              <a:gd name="adj" fmla="val 16667"/>
+            </a:avLst>
+          </a:prstGeom>
+          <a:solidFill>
+            <a:srgbClr val="EDF7F0"/>
+          </a:solidFill>
+          <a:ln w="12700">
+            <a:solidFill>
+              <a:srgbClr val="B7E1C9"/>
+            </a:solidFill>
+            <a:prstDash val="solid"/>
+          </a:ln>
+        </p:spPr>
+      </p:sp>
+      <p:sp>
+        <p:nvSpPr>
+          <p:cNvPr id="28" name="Text 26"/>
+          <p:cNvSpPr/>
+          <p:nvPr/>
+        </p:nvSpPr>
+        <p:spPr>
+          <a:xfrm>
+            <a:off x="4846320" y="3950208"/>
+            <a:ext cx="3749040" cy="329184"/>
+          </a:xfrm>
+          <a:prstGeom prst="rect">
+            <a:avLst/>
+          </a:prstGeom>
+          <a:noFill/>
+          <a:ln/>
+        </p:spPr>
+        <p:txBody>
+          <a:bodyPr wrap="square" lIns="0" tIns="0" rIns="0" bIns="0" rtlCol="0" anchor="ctr"/>
+          <a:lstStyle/>
+          <a:p>
+            <a:pPr indent="0" marL="0">
+              <a:buNone/>
+            </a:pPr>
+            <a:r>
+              <a:rPr lang="en-US" sz="1000" dirty="0">
+                <a:solidFill>
+                  <a:srgbClr val="2D6A4F"/>
+                </a:solidFill>
+                <a:latin typeface="Calibri" pitchFamily="34" charset="0"/>
+                <a:ea typeface="Calibri" pitchFamily="34" charset="-122"/>
+                <a:cs typeface="Calibri" pitchFamily="34" charset="-120"/>
+              </a:rPr>
+              <a:t>✓  file:// URLs fixed to https://</a:t>
+            </a:r>
+            <a:endParaRPr lang="en-US" sz="1000" dirty="0"/>
+          </a:p>
+        </p:txBody>
+      </p:sp>
+      <p:sp>
+        <p:nvSpPr>
+          <p:cNvPr id="29" name="Shape 27"/>
+          <p:cNvSpPr/>
+          <p:nvPr/>
+        </p:nvSpPr>
+        <p:spPr>
+          <a:xfrm>
+            <a:off x="4754880" y="4334256"/>
+            <a:ext cx="3931920" cy="329184"/>
+          </a:xfrm>
+          <a:prstGeom prst="roundRect">
+            <a:avLst>
+              <a:gd name="adj" fmla="val 16667"/>
+            </a:avLst>
+          </a:prstGeom>
+          <a:solidFill>
+            <a:srgbClr val="EDF7F0"/>
+          </a:solidFill>
+          <a:ln w="12700">
+            <a:solidFill>
+              <a:srgbClr val="B7E1C9"/>
+            </a:solidFill>
+            <a:prstDash val="solid"/>
+          </a:ln>
+        </p:spPr>
+      </p:sp>
+      <p:sp>
+        <p:nvSpPr>
+          <p:cNvPr id="30" name="Text 28"/>
+          <p:cNvSpPr/>
+          <p:nvPr/>
+        </p:nvSpPr>
+        <p:spPr>
+          <a:xfrm>
+            <a:off x="4846320" y="4334256"/>
+            <a:ext cx="3749040" cy="329184"/>
+          </a:xfrm>
+          <a:prstGeom prst="rect">
+            <a:avLst/>
+          </a:prstGeom>
+          <a:noFill/>
+          <a:ln/>
+        </p:spPr>
+        <p:txBody>
+          <a:bodyPr wrap="square" lIns="0" tIns="0" rIns="0" bIns="0" rtlCol="0" anchor="ctr"/>
+          <a:lstStyle/>
+          <a:p>
+            <a:pPr indent="0" marL="0">
+              <a:buNone/>
+            </a:pPr>
+            <a:r>
+              <a:rPr lang="en-US" sz="1000" dirty="0">
+                <a:solidFill>
+                  <a:srgbClr val="2D6A4F"/>
+                </a:solidFill>
+                <a:latin typeface="Calibri" pitchFamily="34" charset="0"/>
+                <a:ea typeface="Calibri" pitchFamily="34" charset="-122"/>
+                <a:cs typeface="Calibri" pitchFamily="34" charset="-120"/>
+              </a:rPr>
+              <a:t>✓  Consecutive &lt;strong&gt; tag merging</a:t>
+            </a:r>
+            <a:endParaRPr lang="en-US" sz="1000" dirty="0"/>
           </a:p>
         </p:txBody>
       </p:sp>
@@ -3310,7 +3531,7 @@
                 <a:ea typeface="Calibri" pitchFamily="34" charset="-122"/>
                 <a:cs typeface="Calibri" pitchFamily="34" charset="-120"/>
               </a:rPr>
-              <a:t>• contenteditable HTML</a:t>
+              <a:t>• contenteditable</a:t>
             </a:r>
             <a:endParaRPr lang="en-US" sz="1050" dirty="0"/>
           </a:p>
@@ -3690,7 +3911,7 @@
                 <a:ea typeface="Calibri" pitchFamily="34" charset="-122"/>
                 <a:cs typeface="Calibri" pitchFamily="34" charset="-120"/>
               </a:rPr>
-              <a:t>• 11 rules run</a:t>
+              <a:t>• 14 rules run</a:t>
             </a:r>
             <a:endParaRPr lang="en-US" sz="1050" dirty="0"/>
           </a:p>
@@ -4168,24 +4389,24 @@
         </p:nvSpPr>
         <p:spPr>
           <a:xfrm>
-            <a:off x="457200" y="274320"/>
-            <a:ext cx="8229600" cy="502920"/>
-          </a:xfrm>
-          <a:prstGeom prst="rect">
-            <a:avLst/>
-          </a:prstGeom>
-          <a:noFill/>
-          <a:ln/>
-        </p:spPr>
-        <p:txBody>
-          <a:bodyPr wrap="square" lIns="0" tIns="0" rIns="0" bIns="0" rtlCol="0" anchor="ctr"/>
-          <a:lstStyle/>
-          <a:p>
-            <a:pPr indent="0" marL="0">
-              <a:buNone/>
-            </a:pPr>
-            <a:r>
-              <a:rPr lang="en-US" sz="2800" b="1" dirty="0">
+            <a:off x="457200" y="256032"/>
+            <a:ext cx="8229600" cy="457200"/>
+          </a:xfrm>
+          <a:prstGeom prst="rect">
+            <a:avLst/>
+          </a:prstGeom>
+          <a:noFill/>
+          <a:ln/>
+        </p:spPr>
+        <p:txBody>
+          <a:bodyPr wrap="square" lIns="0" tIns="0" rIns="0" bIns="0" rtlCol="0" anchor="ctr"/>
+          <a:lstStyle/>
+          <a:p>
+            <a:pPr indent="0" marL="0">
+              <a:buNone/>
+            </a:pPr>
+            <a:r>
+              <a:rPr lang="en-US" sz="2600" b="1" dirty="0">
                 <a:solidFill>
                   <a:srgbClr val="1A1A18"/>
                 </a:solidFill>
@@ -4193,9 +4414,9 @@
                 <a:ea typeface="Calibri" pitchFamily="34" charset="-122"/>
                 <a:cs typeface="Calibri" pitchFamily="34" charset="-120"/>
               </a:rPr>
-              <a:t>11 Conversion Rules</a:t>
-            </a:r>
-            <a:endParaRPr lang="en-US" sz="2800" dirty="0"/>
+              <a:t>14 Conversion Rules</a:t>
+            </a:r>
+            <a:endParaRPr lang="en-US" sz="2600" dirty="0"/>
           </a:p>
         </p:txBody>
       </p:sp>
@@ -4207,24 +4428,24 @@
         </p:nvSpPr>
         <p:spPr>
           <a:xfrm>
-            <a:off x="457200" y="822960"/>
-            <a:ext cx="8229600" cy="320040"/>
-          </a:xfrm>
-          <a:prstGeom prst="rect">
-            <a:avLst/>
-          </a:prstGeom>
-          <a:noFill/>
-          <a:ln/>
-        </p:spPr>
-        <p:txBody>
-          <a:bodyPr wrap="square" lIns="0" tIns="0" rIns="0" bIns="0" rtlCol="0" anchor="ctr"/>
-          <a:lstStyle/>
-          <a:p>
-            <a:pPr indent="0" marL="0">
-              <a:buNone/>
-            </a:pPr>
-            <a:r>
-              <a:rPr lang="en-US" sz="1200" dirty="0">
+            <a:off x="457200" y="749808"/>
+            <a:ext cx="8229600" cy="274320"/>
+          </a:xfrm>
+          <a:prstGeom prst="rect">
+            <a:avLst/>
+          </a:prstGeom>
+          <a:noFill/>
+          <a:ln/>
+        </p:spPr>
+        <p:txBody>
+          <a:bodyPr wrap="square" lIns="0" tIns="0" rIns="0" bIns="0" rtlCol="0" anchor="ctr"/>
+          <a:lstStyle/>
+          <a:p>
+            <a:pPr indent="0" marL="0">
+              <a:buNone/>
+            </a:pPr>
+            <a:r>
+              <a:rPr lang="en-US" sz="1150" dirty="0">
                 <a:solidFill>
                   <a:srgbClr val="5A5952"/>
                 </a:solidFill>
@@ -4234,7 +4455,7 @@
               </a:rPr>
               <a:t>Applied identically to file uploads and the text editor — same output, every time.</a:t>
             </a:r>
-            <a:endParaRPr lang="en-US" sz="1200" dirty="0"/>
+            <a:endParaRPr lang="en-US" sz="1150" dirty="0"/>
           </a:p>
         </p:txBody>
       </p:sp>
@@ -4246,12 +4467,12 @@
         </p:nvSpPr>
         <p:spPr>
           <a:xfrm>
-            <a:off x="365760" y="1234440"/>
-            <a:ext cx="4023360" cy="594360"/>
+            <a:off x="365760" y="1115568"/>
+            <a:ext cx="4023360" cy="493776"/>
           </a:xfrm>
           <a:prstGeom prst="roundRect">
             <a:avLst>
-              <a:gd name="adj" fmla="val 12308"/>
+              <a:gd name="adj" fmla="val 14815"/>
             </a:avLst>
           </a:prstGeom>
           <a:solidFill>
@@ -4280,12 +4501,12 @@
         </p:nvSpPr>
         <p:spPr>
           <a:xfrm>
-            <a:off x="365760" y="1234440"/>
-            <a:ext cx="365760" cy="594360"/>
+            <a:off x="365760" y="1115568"/>
+            <a:ext cx="347472" cy="493776"/>
           </a:xfrm>
           <a:prstGeom prst="roundRect">
             <a:avLst>
-              <a:gd name="adj" fmla="val 20000"/>
+              <a:gd name="adj" fmla="val 21053"/>
             </a:avLst>
           </a:prstGeom>
           <a:solidFill>
@@ -4307,8 +4528,8 @@
         </p:nvSpPr>
         <p:spPr>
           <a:xfrm>
-            <a:off x="365760" y="1234440"/>
-            <a:ext cx="365760" cy="594360"/>
+            <a:off x="365760" y="1115568"/>
+            <a:ext cx="347472" cy="493776"/>
           </a:xfrm>
           <a:prstGeom prst="rect">
             <a:avLst/>
@@ -4346,24 +4567,24 @@
         </p:nvSpPr>
         <p:spPr>
           <a:xfrm>
-            <a:off x="804672" y="1271016"/>
-            <a:ext cx="2286000" cy="274320"/>
-          </a:xfrm>
-          <a:prstGeom prst="rect">
-            <a:avLst/>
-          </a:prstGeom>
-          <a:noFill/>
-          <a:ln/>
-        </p:spPr>
-        <p:txBody>
-          <a:bodyPr wrap="square" lIns="0" tIns="0" rIns="0" bIns="0" rtlCol="0" anchor="ctr"/>
-          <a:lstStyle/>
-          <a:p>
-            <a:pPr indent="0" marL="0">
-              <a:buNone/>
-            </a:pPr>
-            <a:r>
-              <a:rPr lang="en-US" sz="1050" b="1" dirty="0">
+            <a:off x="786384" y="1143000"/>
+            <a:ext cx="2286000" cy="228600"/>
+          </a:xfrm>
+          <a:prstGeom prst="rect">
+            <a:avLst/>
+          </a:prstGeom>
+          <a:noFill/>
+          <a:ln/>
+        </p:spPr>
+        <p:txBody>
+          <a:bodyPr wrap="square" lIns="0" tIns="0" rIns="0" bIns="0" rtlCol="0" anchor="ctr"/>
+          <a:lstStyle/>
+          <a:p>
+            <a:pPr indent="0" marL="0">
+              <a:buNone/>
+            </a:pPr>
+            <a:r>
+              <a:rPr lang="en-US" sz="1000" b="1" dirty="0">
                 <a:solidFill>
                   <a:srgbClr val="1A1A18"/>
                 </a:solidFill>
@@ -4373,7 +4594,7 @@
               </a:rPr>
               <a:t>h1 → h2</a:t>
             </a:r>
-            <a:endParaRPr lang="en-US" sz="1050" dirty="0"/>
+            <a:endParaRPr lang="en-US" sz="1000" dirty="0"/>
           </a:p>
         </p:txBody>
       </p:sp>
@@ -4385,24 +4606,24 @@
         </p:nvSpPr>
         <p:spPr>
           <a:xfrm>
-            <a:off x="804672" y="1527048"/>
-            <a:ext cx="3474720" cy="256032"/>
-          </a:xfrm>
-          <a:prstGeom prst="rect">
-            <a:avLst/>
-          </a:prstGeom>
-          <a:noFill/>
-          <a:ln/>
-        </p:spPr>
-        <p:txBody>
-          <a:bodyPr wrap="square" lIns="0" tIns="0" rIns="0" bIns="0" rtlCol="0" anchor="ctr"/>
-          <a:lstStyle/>
-          <a:p>
-            <a:pPr indent="0" marL="0">
-              <a:buNone/>
-            </a:pPr>
-            <a:r>
-              <a:rPr lang="en-US" sz="900" dirty="0">
+            <a:off x="786384" y="1371600"/>
+            <a:ext cx="3474720" cy="201168"/>
+          </a:xfrm>
+          <a:prstGeom prst="rect">
+            <a:avLst/>
+          </a:prstGeom>
+          <a:noFill/>
+          <a:ln/>
+        </p:spPr>
+        <p:txBody>
+          <a:bodyPr wrap="square" lIns="0" tIns="0" rIns="0" bIns="0" rtlCol="0" anchor="ctr"/>
+          <a:lstStyle/>
+          <a:p>
+            <a:pPr indent="0" marL="0">
+              <a:buNone/>
+            </a:pPr>
+            <a:r>
+              <a:rPr lang="en-US" sz="850" dirty="0">
                 <a:solidFill>
                   <a:srgbClr val="5A5952"/>
                 </a:solidFill>
@@ -4412,7 +4633,7 @@
               </a:rPr>
               <a:t>&lt;h1&gt; becomes &lt;h2&gt;</a:t>
             </a:r>
-            <a:endParaRPr lang="en-US" sz="900" dirty="0"/>
+            <a:endParaRPr lang="en-US" sz="850" dirty="0"/>
           </a:p>
         </p:txBody>
       </p:sp>
@@ -4424,12 +4645,12 @@
         </p:nvSpPr>
         <p:spPr>
           <a:xfrm>
-            <a:off x="365760" y="1920240"/>
-            <a:ext cx="4023360" cy="594360"/>
+            <a:off x="365760" y="1682496"/>
+            <a:ext cx="4023360" cy="493776"/>
           </a:xfrm>
           <a:prstGeom prst="roundRect">
             <a:avLst>
-              <a:gd name="adj" fmla="val 12308"/>
+              <a:gd name="adj" fmla="val 14815"/>
             </a:avLst>
           </a:prstGeom>
           <a:solidFill>
@@ -4458,12 +4679,12 @@
         </p:nvSpPr>
         <p:spPr>
           <a:xfrm>
-            <a:off x="365760" y="1920240"/>
-            <a:ext cx="365760" cy="594360"/>
+            <a:off x="365760" y="1682496"/>
+            <a:ext cx="347472" cy="493776"/>
           </a:xfrm>
           <a:prstGeom prst="roundRect">
             <a:avLst>
-              <a:gd name="adj" fmla="val 20000"/>
+              <a:gd name="adj" fmla="val 21053"/>
             </a:avLst>
           </a:prstGeom>
           <a:solidFill>
@@ -4485,8 +4706,8 @@
         </p:nvSpPr>
         <p:spPr>
           <a:xfrm>
-            <a:off x="365760" y="1920240"/>
-            <a:ext cx="365760" cy="594360"/>
+            <a:off x="365760" y="1682496"/>
+            <a:ext cx="347472" cy="493776"/>
           </a:xfrm>
           <a:prstGeom prst="rect">
             <a:avLst/>
@@ -4524,24 +4745,24 @@
         </p:nvSpPr>
         <p:spPr>
           <a:xfrm>
-            <a:off x="804672" y="1956816"/>
-            <a:ext cx="2286000" cy="274320"/>
-          </a:xfrm>
-          <a:prstGeom prst="rect">
-            <a:avLst/>
-          </a:prstGeom>
-          <a:noFill/>
-          <a:ln/>
-        </p:spPr>
-        <p:txBody>
-          <a:bodyPr wrap="square" lIns="0" tIns="0" rIns="0" bIns="0" rtlCol="0" anchor="ctr"/>
-          <a:lstStyle/>
-          <a:p>
-            <a:pPr indent="0" marL="0">
-              <a:buNone/>
-            </a:pPr>
-            <a:r>
-              <a:rPr lang="en-US" sz="1050" b="1" dirty="0">
+            <a:off x="786384" y="1709928"/>
+            <a:ext cx="2286000" cy="228600"/>
+          </a:xfrm>
+          <a:prstGeom prst="rect">
+            <a:avLst/>
+          </a:prstGeom>
+          <a:noFill/>
+          <a:ln/>
+        </p:spPr>
+        <p:txBody>
+          <a:bodyPr wrap="square" lIns="0" tIns="0" rIns="0" bIns="0" rtlCol="0" anchor="ctr"/>
+          <a:lstStyle/>
+          <a:p>
+            <a:pPr indent="0" marL="0">
+              <a:buNone/>
+            </a:pPr>
+            <a:r>
+              <a:rPr lang="en-US" sz="1000" b="1" dirty="0">
                 <a:solidFill>
                   <a:srgbClr val="1A1A18"/>
                 </a:solidFill>
@@ -4551,7 +4772,7 @@
               </a:rPr>
               <a:t>Phone → tel: link</a:t>
             </a:r>
-            <a:endParaRPr lang="en-US" sz="1050" dirty="0"/>
+            <a:endParaRPr lang="en-US" sz="1000" dirty="0"/>
           </a:p>
         </p:txBody>
       </p:sp>
@@ -4563,24 +4784,24 @@
         </p:nvSpPr>
         <p:spPr>
           <a:xfrm>
-            <a:off x="804672" y="2212848"/>
-            <a:ext cx="3474720" cy="256032"/>
-          </a:xfrm>
-          <a:prstGeom prst="rect">
-            <a:avLst/>
-          </a:prstGeom>
-          <a:noFill/>
-          <a:ln/>
-        </p:spPr>
-        <p:txBody>
-          <a:bodyPr wrap="square" lIns="0" tIns="0" rIns="0" bIns="0" rtlCol="0" anchor="ctr"/>
-          <a:lstStyle/>
-          <a:p>
-            <a:pPr indent="0" marL="0">
-              <a:buNone/>
-            </a:pPr>
-            <a:r>
-              <a:rPr lang="en-US" sz="900" dirty="0">
+            <a:off x="786384" y="1938528"/>
+            <a:ext cx="3474720" cy="201168"/>
+          </a:xfrm>
+          <a:prstGeom prst="rect">
+            <a:avLst/>
+          </a:prstGeom>
+          <a:noFill/>
+          <a:ln/>
+        </p:spPr>
+        <p:txBody>
+          <a:bodyPr wrap="square" lIns="0" tIns="0" rIns="0" bIns="0" rtlCol="0" anchor="ctr"/>
+          <a:lstStyle/>
+          <a:p>
+            <a:pPr indent="0" marL="0">
+              <a:buNone/>
+            </a:pPr>
+            <a:r>
+              <a:rPr lang="en-US" sz="850" dirty="0">
                 <a:solidFill>
                   <a:srgbClr val="5A5952"/>
                 </a:solidFill>
@@ -4590,7 +4811,7 @@
               </a:rPr>
               <a:t>Fax numbers excluded</a:t>
             </a:r>
-            <a:endParaRPr lang="en-US" sz="900" dirty="0"/>
+            <a:endParaRPr lang="en-US" sz="850" dirty="0"/>
           </a:p>
         </p:txBody>
       </p:sp>
@@ -4602,12 +4823,12 @@
         </p:nvSpPr>
         <p:spPr>
           <a:xfrm>
-            <a:off x="365760" y="2606040"/>
-            <a:ext cx="4023360" cy="594360"/>
+            <a:off x="365760" y="2249424"/>
+            <a:ext cx="4023360" cy="493776"/>
           </a:xfrm>
           <a:prstGeom prst="roundRect">
             <a:avLst>
-              <a:gd name="adj" fmla="val 12308"/>
+              <a:gd name="adj" fmla="val 14815"/>
             </a:avLst>
           </a:prstGeom>
           <a:solidFill>
@@ -4636,12 +4857,12 @@
         </p:nvSpPr>
         <p:spPr>
           <a:xfrm>
-            <a:off x="365760" y="2606040"/>
-            <a:ext cx="365760" cy="594360"/>
+            <a:off x="365760" y="2249424"/>
+            <a:ext cx="347472" cy="493776"/>
           </a:xfrm>
           <a:prstGeom prst="roundRect">
             <a:avLst>
-              <a:gd name="adj" fmla="val 20000"/>
+              <a:gd name="adj" fmla="val 21053"/>
             </a:avLst>
           </a:prstGeom>
           <a:solidFill>
@@ -4663,8 +4884,8 @@
         </p:nvSpPr>
         <p:spPr>
           <a:xfrm>
-            <a:off x="365760" y="2606040"/>
-            <a:ext cx="365760" cy="594360"/>
+            <a:off x="365760" y="2249424"/>
+            <a:ext cx="347472" cy="493776"/>
           </a:xfrm>
           <a:prstGeom prst="rect">
             <a:avLst/>
@@ -4702,24 +4923,24 @@
         </p:nvSpPr>
         <p:spPr>
           <a:xfrm>
-            <a:off x="804672" y="2642616"/>
-            <a:ext cx="2286000" cy="274320"/>
-          </a:xfrm>
-          <a:prstGeom prst="rect">
-            <a:avLst/>
-          </a:prstGeom>
-          <a:noFill/>
-          <a:ln/>
-        </p:spPr>
-        <p:txBody>
-          <a:bodyPr wrap="square" lIns="0" tIns="0" rIns="0" bIns="0" rtlCol="0" anchor="ctr"/>
-          <a:lstStyle/>
-          <a:p>
-            <a:pPr indent="0" marL="0">
-              <a:buNone/>
-            </a:pPr>
-            <a:r>
-              <a:rPr lang="en-US" sz="1050" b="1" dirty="0">
+            <a:off x="786384" y="2276856"/>
+            <a:ext cx="2286000" cy="228600"/>
+          </a:xfrm>
+          <a:prstGeom prst="rect">
+            <a:avLst/>
+          </a:prstGeom>
+          <a:noFill/>
+          <a:ln/>
+        </p:spPr>
+        <p:txBody>
+          <a:bodyPr wrap="square" lIns="0" tIns="0" rIns="0" bIns="0" rtlCol="0" anchor="ctr"/>
+          <a:lstStyle/>
+          <a:p>
+            <a:pPr indent="0" marL="0">
+              <a:buNone/>
+            </a:pPr>
+            <a:r>
+              <a:rPr lang="en-US" sz="1000" b="1" dirty="0">
                 <a:solidFill>
                   <a:srgbClr val="1A1A18"/>
                 </a:solidFill>
@@ -4729,7 +4950,7 @@
               </a:rPr>
               <a:t>Sup/Sub → Unicode</a:t>
             </a:r>
-            <a:endParaRPr lang="en-US" sz="1050" dirty="0"/>
+            <a:endParaRPr lang="en-US" sz="1000" dirty="0"/>
           </a:p>
         </p:txBody>
       </p:sp>
@@ -4741,24 +4962,24 @@
         </p:nvSpPr>
         <p:spPr>
           <a:xfrm>
-            <a:off x="804672" y="2898648"/>
-            <a:ext cx="3474720" cy="256032"/>
-          </a:xfrm>
-          <a:prstGeom prst="rect">
-            <a:avLst/>
-          </a:prstGeom>
-          <a:noFill/>
-          <a:ln/>
-        </p:spPr>
-        <p:txBody>
-          <a:bodyPr wrap="square" lIns="0" tIns="0" rIns="0" bIns="0" rtlCol="0" anchor="ctr"/>
-          <a:lstStyle/>
-          <a:p>
-            <a:pPr indent="0" marL="0">
-              <a:buNone/>
-            </a:pPr>
-            <a:r>
-              <a:rPr lang="en-US" sz="900" dirty="0">
+            <a:off x="786384" y="2505456"/>
+            <a:ext cx="3474720" cy="201168"/>
+          </a:xfrm>
+          <a:prstGeom prst="rect">
+            <a:avLst/>
+          </a:prstGeom>
+          <a:noFill/>
+          <a:ln/>
+        </p:spPr>
+        <p:txBody>
+          <a:bodyPr wrap="square" lIns="0" tIns="0" rIns="0" bIns="0" rtlCol="0" anchor="ctr"/>
+          <a:lstStyle/>
+          <a:p>
+            <a:pPr indent="0" marL="0">
+              <a:buNone/>
+            </a:pPr>
+            <a:r>
+              <a:rPr lang="en-US" sz="850" dirty="0">
                 <a:solidFill>
                   <a:srgbClr val="5A5952"/>
                 </a:solidFill>
@@ -4768,7 +4989,7 @@
               </a:rPr>
               <a:t>&lt;sup&gt;TM&lt;/sup&gt; → &amp;trade;</a:t>
             </a:r>
-            <a:endParaRPr lang="en-US" sz="900" dirty="0"/>
+            <a:endParaRPr lang="en-US" sz="850" dirty="0"/>
           </a:p>
         </p:txBody>
       </p:sp>
@@ -4780,12 +5001,12 @@
         </p:nvSpPr>
         <p:spPr>
           <a:xfrm>
-            <a:off x="365760" y="3291840"/>
-            <a:ext cx="4023360" cy="594360"/>
+            <a:off x="365760" y="2816352"/>
+            <a:ext cx="4023360" cy="493776"/>
           </a:xfrm>
           <a:prstGeom prst="roundRect">
             <a:avLst>
-              <a:gd name="adj" fmla="val 12308"/>
+              <a:gd name="adj" fmla="val 14815"/>
             </a:avLst>
           </a:prstGeom>
           <a:solidFill>
@@ -4814,12 +5035,12 @@
         </p:nvSpPr>
         <p:spPr>
           <a:xfrm>
-            <a:off x="365760" y="3291840"/>
-            <a:ext cx="365760" cy="594360"/>
+            <a:off x="365760" y="2816352"/>
+            <a:ext cx="347472" cy="493776"/>
           </a:xfrm>
           <a:prstGeom prst="roundRect">
             <a:avLst>
-              <a:gd name="adj" fmla="val 20000"/>
+              <a:gd name="adj" fmla="val 21053"/>
             </a:avLst>
           </a:prstGeom>
           <a:solidFill>
@@ -4841,8 +5062,8 @@
         </p:nvSpPr>
         <p:spPr>
           <a:xfrm>
-            <a:off x="365760" y="3291840"/>
-            <a:ext cx="365760" cy="594360"/>
+            <a:off x="365760" y="2816352"/>
+            <a:ext cx="347472" cy="493776"/>
           </a:xfrm>
           <a:prstGeom prst="rect">
             <a:avLst/>
@@ -4880,24 +5101,24 @@
         </p:nvSpPr>
         <p:spPr>
           <a:xfrm>
-            <a:off x="804672" y="3328416"/>
-            <a:ext cx="2286000" cy="274320"/>
-          </a:xfrm>
-          <a:prstGeom prst="rect">
-            <a:avLst/>
-          </a:prstGeom>
-          <a:noFill/>
-          <a:ln/>
-        </p:spPr>
-        <p:txBody>
-          <a:bodyPr wrap="square" lIns="0" tIns="0" rIns="0" bIns="0" rtlCol="0" anchor="ctr"/>
-          <a:lstStyle/>
-          <a:p>
-            <a:pPr indent="0" marL="0">
-              <a:buNone/>
-            </a:pPr>
-            <a:r>
-              <a:rPr lang="en-US" sz="1050" b="1" dirty="0">
+            <a:off x="786384" y="2843784"/>
+            <a:ext cx="2286000" cy="228600"/>
+          </a:xfrm>
+          <a:prstGeom prst="rect">
+            <a:avLst/>
+          </a:prstGeom>
+          <a:noFill/>
+          <a:ln/>
+        </p:spPr>
+        <p:txBody>
+          <a:bodyPr wrap="square" lIns="0" tIns="0" rIns="0" bIns="0" rtlCol="0" anchor="ctr"/>
+          <a:lstStyle/>
+          <a:p>
+            <a:pPr indent="0" marL="0">
+              <a:buNone/>
+            </a:pPr>
+            <a:r>
+              <a:rPr lang="en-US" sz="1000" b="1" dirty="0">
                 <a:solidFill>
                   <a:srgbClr val="1A1A18"/>
                 </a:solidFill>
@@ -4907,7 +5128,7 @@
               </a:rPr>
               <a:t>b → strong</a:t>
             </a:r>
-            <a:endParaRPr lang="en-US" sz="1050" dirty="0"/>
+            <a:endParaRPr lang="en-US" sz="1000" dirty="0"/>
           </a:p>
         </p:txBody>
       </p:sp>
@@ -4919,24 +5140,24 @@
         </p:nvSpPr>
         <p:spPr>
           <a:xfrm>
-            <a:off x="804672" y="3584448"/>
-            <a:ext cx="3474720" cy="256032"/>
-          </a:xfrm>
-          <a:prstGeom prst="rect">
-            <a:avLst/>
-          </a:prstGeom>
-          <a:noFill/>
-          <a:ln/>
-        </p:spPr>
-        <p:txBody>
-          <a:bodyPr wrap="square" lIns="0" tIns="0" rIns="0" bIns="0" rtlCol="0" anchor="ctr"/>
-          <a:lstStyle/>
-          <a:p>
-            <a:pPr indent="0" marL="0">
-              <a:buNone/>
-            </a:pPr>
-            <a:r>
-              <a:rPr lang="en-US" sz="900" dirty="0">
+            <a:off x="786384" y="3072384"/>
+            <a:ext cx="3474720" cy="201168"/>
+          </a:xfrm>
+          <a:prstGeom prst="rect">
+            <a:avLst/>
+          </a:prstGeom>
+          <a:noFill/>
+          <a:ln/>
+        </p:spPr>
+        <p:txBody>
+          <a:bodyPr wrap="square" lIns="0" tIns="0" rIns="0" bIns="0" rtlCol="0" anchor="ctr"/>
+          <a:lstStyle/>
+          <a:p>
+            <a:pPr indent="0" marL="0">
+              <a:buNone/>
+            </a:pPr>
+            <a:r>
+              <a:rPr lang="en-US" sz="850" dirty="0">
                 <a:solidFill>
                   <a:srgbClr val="5A5952"/>
                 </a:solidFill>
@@ -4946,7 +5167,7 @@
               </a:rPr>
               <a:t>&lt;b&gt; becomes &lt;strong&gt;</a:t>
             </a:r>
-            <a:endParaRPr lang="en-US" sz="900" dirty="0"/>
+            <a:endParaRPr lang="en-US" sz="850" dirty="0"/>
           </a:p>
         </p:txBody>
       </p:sp>
@@ -4958,12 +5179,12 @@
         </p:nvSpPr>
         <p:spPr>
           <a:xfrm>
-            <a:off x="365760" y="3977640"/>
-            <a:ext cx="4023360" cy="594360"/>
+            <a:off x="365760" y="3383280"/>
+            <a:ext cx="4023360" cy="493776"/>
           </a:xfrm>
           <a:prstGeom prst="roundRect">
             <a:avLst>
-              <a:gd name="adj" fmla="val 12308"/>
+              <a:gd name="adj" fmla="val 14815"/>
             </a:avLst>
           </a:prstGeom>
           <a:solidFill>
@@ -4992,12 +5213,12 @@
         </p:nvSpPr>
         <p:spPr>
           <a:xfrm>
-            <a:off x="365760" y="3977640"/>
-            <a:ext cx="365760" cy="594360"/>
+            <a:off x="365760" y="3383280"/>
+            <a:ext cx="347472" cy="493776"/>
           </a:xfrm>
           <a:prstGeom prst="roundRect">
             <a:avLst>
-              <a:gd name="adj" fmla="val 20000"/>
+              <a:gd name="adj" fmla="val 21053"/>
             </a:avLst>
           </a:prstGeom>
           <a:solidFill>
@@ -5019,8 +5240,8 @@
         </p:nvSpPr>
         <p:spPr>
           <a:xfrm>
-            <a:off x="365760" y="3977640"/>
-            <a:ext cx="365760" cy="594360"/>
+            <a:off x="365760" y="3383280"/>
+            <a:ext cx="347472" cy="493776"/>
           </a:xfrm>
           <a:prstGeom prst="rect">
             <a:avLst/>
@@ -5058,24 +5279,24 @@
         </p:nvSpPr>
         <p:spPr>
           <a:xfrm>
-            <a:off x="804672" y="4014216"/>
-            <a:ext cx="2286000" cy="274320"/>
-          </a:xfrm>
-          <a:prstGeom prst="rect">
-            <a:avLst/>
-          </a:prstGeom>
-          <a:noFill/>
-          <a:ln/>
-        </p:spPr>
-        <p:txBody>
-          <a:bodyPr wrap="square" lIns="0" tIns="0" rIns="0" bIns="0" rtlCol="0" anchor="ctr"/>
-          <a:lstStyle/>
-          <a:p>
-            <a:pPr indent="0" marL="0">
-              <a:buNone/>
-            </a:pPr>
-            <a:r>
-              <a:rPr lang="en-US" sz="1050" b="1" dirty="0">
+            <a:off x="786384" y="3410712"/>
+            <a:ext cx="2286000" cy="228600"/>
+          </a:xfrm>
+          <a:prstGeom prst="rect">
+            <a:avLst/>
+          </a:prstGeom>
+          <a:noFill/>
+          <a:ln/>
+        </p:spPr>
+        <p:txBody>
+          <a:bodyPr wrap="square" lIns="0" tIns="0" rIns="0" bIns="0" rtlCol="0" anchor="ctr"/>
+          <a:lstStyle/>
+          <a:p>
+            <a:pPr indent="0" marL="0">
+              <a:buNone/>
+            </a:pPr>
+            <a:r>
+              <a:rPr lang="en-US" sz="1000" b="1" dirty="0">
                 <a:solidFill>
                   <a:srgbClr val="1A1A18"/>
                 </a:solidFill>
@@ -5085,7 +5306,7 @@
               </a:rPr>
               <a:t>i/em → strong</a:t>
             </a:r>
-            <a:endParaRPr lang="en-US" sz="1050" dirty="0"/>
+            <a:endParaRPr lang="en-US" sz="1000" dirty="0"/>
           </a:p>
         </p:txBody>
       </p:sp>
@@ -5097,24 +5318,24 @@
         </p:nvSpPr>
         <p:spPr>
           <a:xfrm>
-            <a:off x="804672" y="4270248"/>
-            <a:ext cx="3474720" cy="256032"/>
-          </a:xfrm>
-          <a:prstGeom prst="rect">
-            <a:avLst/>
-          </a:prstGeom>
-          <a:noFill/>
-          <a:ln/>
-        </p:spPr>
-        <p:txBody>
-          <a:bodyPr wrap="square" lIns="0" tIns="0" rIns="0" bIns="0" rtlCol="0" anchor="ctr"/>
-          <a:lstStyle/>
-          <a:p>
-            <a:pPr indent="0" marL="0">
-              <a:buNone/>
-            </a:pPr>
-            <a:r>
-              <a:rPr lang="en-US" sz="900" dirty="0">
+            <a:off x="786384" y="3639312"/>
+            <a:ext cx="3474720" cy="201168"/>
+          </a:xfrm>
+          <a:prstGeom prst="rect">
+            <a:avLst/>
+          </a:prstGeom>
+          <a:noFill/>
+          <a:ln/>
+        </p:spPr>
+        <p:txBody>
+          <a:bodyPr wrap="square" lIns="0" tIns="0" rIns="0" bIns="0" rtlCol="0" anchor="ctr"/>
+          <a:lstStyle/>
+          <a:p>
+            <a:pPr indent="0" marL="0">
+              <a:buNone/>
+            </a:pPr>
+            <a:r>
+              <a:rPr lang="en-US" sz="850" dirty="0">
                 <a:solidFill>
                   <a:srgbClr val="5A5952"/>
                 </a:solidFill>
@@ -5124,7 +5345,7 @@
               </a:rPr>
               <a:t>Short italic → bold</a:t>
             </a:r>
-            <a:endParaRPr lang="en-US" sz="900" dirty="0"/>
+            <a:endParaRPr lang="en-US" sz="850" dirty="0"/>
           </a:p>
         </p:txBody>
       </p:sp>
@@ -5136,12 +5357,12 @@
         </p:nvSpPr>
         <p:spPr>
           <a:xfrm>
-            <a:off x="4663440" y="1234440"/>
-            <a:ext cx="4023360" cy="594360"/>
+            <a:off x="365760" y="3950208"/>
+            <a:ext cx="4023360" cy="493776"/>
           </a:xfrm>
           <a:prstGeom prst="roundRect">
             <a:avLst>
-              <a:gd name="adj" fmla="val 12308"/>
+              <a:gd name="adj" fmla="val 14815"/>
             </a:avLst>
           </a:prstGeom>
           <a:solidFill>
@@ -5170,12 +5391,12 @@
         </p:nvSpPr>
         <p:spPr>
           <a:xfrm>
-            <a:off x="4663440" y="1234440"/>
-            <a:ext cx="365760" cy="594360"/>
+            <a:off x="365760" y="3950208"/>
+            <a:ext cx="347472" cy="493776"/>
           </a:xfrm>
           <a:prstGeom prst="roundRect">
             <a:avLst>
-              <a:gd name="adj" fmla="val 20000"/>
+              <a:gd name="adj" fmla="val 21053"/>
             </a:avLst>
           </a:prstGeom>
           <a:solidFill>
@@ -5197,8 +5418,8 @@
         </p:nvSpPr>
         <p:spPr>
           <a:xfrm>
-            <a:off x="4663440" y="1234440"/>
-            <a:ext cx="365760" cy="594360"/>
+            <a:off x="365760" y="3950208"/>
+            <a:ext cx="347472" cy="493776"/>
           </a:xfrm>
           <a:prstGeom prst="rect">
             <a:avLst/>
@@ -5236,24 +5457,24 @@
         </p:nvSpPr>
         <p:spPr>
           <a:xfrm>
-            <a:off x="5102352" y="1271016"/>
-            <a:ext cx="2286000" cy="274320"/>
-          </a:xfrm>
-          <a:prstGeom prst="rect">
-            <a:avLst/>
-          </a:prstGeom>
-          <a:noFill/>
-          <a:ln/>
-        </p:spPr>
-        <p:txBody>
-          <a:bodyPr wrap="square" lIns="0" tIns="0" rIns="0" bIns="0" rtlCol="0" anchor="ctr"/>
-          <a:lstStyle/>
-          <a:p>
-            <a:pPr indent="0" marL="0">
-              <a:buNone/>
-            </a:pPr>
-            <a:r>
-              <a:rPr lang="en-US" sz="1050" b="1" dirty="0">
+            <a:off x="786384" y="3977640"/>
+            <a:ext cx="2286000" cy="228600"/>
+          </a:xfrm>
+          <a:prstGeom prst="rect">
+            <a:avLst/>
+          </a:prstGeom>
+          <a:noFill/>
+          <a:ln/>
+        </p:spPr>
+        <p:txBody>
+          <a:bodyPr wrap="square" lIns="0" tIns="0" rIns="0" bIns="0" rtlCol="0" anchor="ctr"/>
+          <a:lstStyle/>
+          <a:p>
+            <a:pPr indent="0" marL="0">
+              <a:buNone/>
+            </a:pPr>
+            <a:r>
+              <a:rPr lang="en-US" sz="1000" b="1" dirty="0">
                 <a:solidFill>
                   <a:srgbClr val="1A1A18"/>
                 </a:solidFill>
@@ -5263,7 +5484,7 @@
               </a:rPr>
               <a:t>Remove underline</a:t>
             </a:r>
-            <a:endParaRPr lang="en-US" sz="1050" dirty="0"/>
+            <a:endParaRPr lang="en-US" sz="1000" dirty="0"/>
           </a:p>
         </p:txBody>
       </p:sp>
@@ -5275,24 +5496,24 @@
         </p:nvSpPr>
         <p:spPr>
           <a:xfrm>
-            <a:off x="5102352" y="1527048"/>
-            <a:ext cx="3474720" cy="256032"/>
-          </a:xfrm>
-          <a:prstGeom prst="rect">
-            <a:avLst/>
-          </a:prstGeom>
-          <a:noFill/>
-          <a:ln/>
-        </p:spPr>
-        <p:txBody>
-          <a:bodyPr wrap="square" lIns="0" tIns="0" rIns="0" bIns="0" rtlCol="0" anchor="ctr"/>
-          <a:lstStyle/>
-          <a:p>
-            <a:pPr indent="0" marL="0">
-              <a:buNone/>
-            </a:pPr>
-            <a:r>
-              <a:rPr lang="en-US" sz="900" dirty="0">
+            <a:off x="786384" y="4206240"/>
+            <a:ext cx="3474720" cy="201168"/>
+          </a:xfrm>
+          <a:prstGeom prst="rect">
+            <a:avLst/>
+          </a:prstGeom>
+          <a:noFill/>
+          <a:ln/>
+        </p:spPr>
+        <p:txBody>
+          <a:bodyPr wrap="square" lIns="0" tIns="0" rIns="0" bIns="0" rtlCol="0" anchor="ctr"/>
+          <a:lstStyle/>
+          <a:p>
+            <a:pPr indent="0" marL="0">
+              <a:buNone/>
+            </a:pPr>
+            <a:r>
+              <a:rPr lang="en-US" sz="850" dirty="0">
                 <a:solidFill>
                   <a:srgbClr val="5A5952"/>
                 </a:solidFill>
@@ -5302,7 +5523,7 @@
               </a:rPr>
               <a:t>&lt;u&gt; unwrapped, text kept</a:t>
             </a:r>
-            <a:endParaRPr lang="en-US" sz="900" dirty="0"/>
+            <a:endParaRPr lang="en-US" sz="850" dirty="0"/>
           </a:p>
         </p:txBody>
       </p:sp>
@@ -5314,12 +5535,12 @@
         </p:nvSpPr>
         <p:spPr>
           <a:xfrm>
-            <a:off x="4663440" y="1920240"/>
-            <a:ext cx="4023360" cy="594360"/>
+            <a:off x="4663440" y="1115568"/>
+            <a:ext cx="4023360" cy="493776"/>
           </a:xfrm>
           <a:prstGeom prst="roundRect">
             <a:avLst>
-              <a:gd name="adj" fmla="val 12308"/>
+              <a:gd name="adj" fmla="val 14815"/>
             </a:avLst>
           </a:prstGeom>
           <a:solidFill>
@@ -5348,12 +5569,12 @@
         </p:nvSpPr>
         <p:spPr>
           <a:xfrm>
-            <a:off x="4663440" y="1920240"/>
-            <a:ext cx="365760" cy="594360"/>
+            <a:off x="4663440" y="1115568"/>
+            <a:ext cx="347472" cy="493776"/>
           </a:xfrm>
           <a:prstGeom prst="roundRect">
             <a:avLst>
-              <a:gd name="adj" fmla="val 20000"/>
+              <a:gd name="adj" fmla="val 21053"/>
             </a:avLst>
           </a:prstGeom>
           <a:solidFill>
@@ -5375,8 +5596,8 @@
         </p:nvSpPr>
         <p:spPr>
           <a:xfrm>
-            <a:off x="4663440" y="1920240"/>
-            <a:ext cx="365760" cy="594360"/>
+            <a:off x="4663440" y="1115568"/>
+            <a:ext cx="347472" cy="493776"/>
           </a:xfrm>
           <a:prstGeom prst="rect">
             <a:avLst/>
@@ -5414,24 +5635,24 @@
         </p:nvSpPr>
         <p:spPr>
           <a:xfrm>
-            <a:off x="5102352" y="1956816"/>
-            <a:ext cx="2286000" cy="274320"/>
-          </a:xfrm>
-          <a:prstGeom prst="rect">
-            <a:avLst/>
-          </a:prstGeom>
-          <a:noFill/>
-          <a:ln/>
-        </p:spPr>
-        <p:txBody>
-          <a:bodyPr wrap="square" lIns="0" tIns="0" rIns="0" bIns="0" rtlCol="0" anchor="ctr"/>
-          <a:lstStyle/>
-          <a:p>
-            <a:pPr indent="0" marL="0">
-              <a:buNone/>
-            </a:pPr>
-            <a:r>
-              <a:rPr lang="en-US" sz="1050" b="1" dirty="0">
+            <a:off x="5084064" y="1143000"/>
+            <a:ext cx="2286000" cy="228600"/>
+          </a:xfrm>
+          <a:prstGeom prst="rect">
+            <a:avLst/>
+          </a:prstGeom>
+          <a:noFill/>
+          <a:ln/>
+        </p:spPr>
+        <p:txBody>
+          <a:bodyPr wrap="square" lIns="0" tIns="0" rIns="0" bIns="0" rtlCol="0" anchor="ctr"/>
+          <a:lstStyle/>
+          <a:p>
+            <a:pPr indent="0" marL="0">
+              <a:buNone/>
+            </a:pPr>
+            <a:r>
+              <a:rPr lang="en-US" sz="1000" b="1" dirty="0">
                 <a:solidFill>
                   <a:srgbClr val="1A1A18"/>
                 </a:solidFill>
@@ -5441,7 +5662,7 @@
               </a:rPr>
               <a:t>Strip MSO junk</a:t>
             </a:r>
-            <a:endParaRPr lang="en-US" sz="1050" dirty="0"/>
+            <a:endParaRPr lang="en-US" sz="1000" dirty="0"/>
           </a:p>
         </p:txBody>
       </p:sp>
@@ -5453,24 +5674,24 @@
         </p:nvSpPr>
         <p:spPr>
           <a:xfrm>
-            <a:off x="5102352" y="2212848"/>
-            <a:ext cx="3474720" cy="256032"/>
-          </a:xfrm>
-          <a:prstGeom prst="rect">
-            <a:avLst/>
-          </a:prstGeom>
-          <a:noFill/>
-          <a:ln/>
-        </p:spPr>
-        <p:txBody>
-          <a:bodyPr wrap="square" lIns="0" tIns="0" rIns="0" bIns="0" rtlCol="0" anchor="ctr"/>
-          <a:lstStyle/>
-          <a:p>
-            <a:pPr indent="0" marL="0">
-              <a:buNone/>
-            </a:pPr>
-            <a:r>
-              <a:rPr lang="en-US" sz="900" dirty="0">
+            <a:off x="5084064" y="1371600"/>
+            <a:ext cx="3474720" cy="201168"/>
+          </a:xfrm>
+          <a:prstGeom prst="rect">
+            <a:avLst/>
+          </a:prstGeom>
+          <a:noFill/>
+          <a:ln/>
+        </p:spPr>
+        <p:txBody>
+          <a:bodyPr wrap="square" lIns="0" tIns="0" rIns="0" bIns="0" rtlCol="0" anchor="ctr"/>
+          <a:lstStyle/>
+          <a:p>
+            <a:pPr indent="0" marL="0">
+              <a:buNone/>
+            </a:pPr>
+            <a:r>
+              <a:rPr lang="en-US" sz="850" dirty="0">
                 <a:solidFill>
                   <a:srgbClr val="5A5952"/>
                 </a:solidFill>
@@ -5480,7 +5701,7 @@
               </a:rPr>
               <a:t>&lt;xml&gt;, &lt;!--[if mso]--&gt; removed</a:t>
             </a:r>
-            <a:endParaRPr lang="en-US" sz="900" dirty="0"/>
+            <a:endParaRPr lang="en-US" sz="850" dirty="0"/>
           </a:p>
         </p:txBody>
       </p:sp>
@@ -5492,12 +5713,12 @@
         </p:nvSpPr>
         <p:spPr>
           <a:xfrm>
-            <a:off x="4663440" y="2606040"/>
-            <a:ext cx="4023360" cy="594360"/>
+            <a:off x="4663440" y="1682496"/>
+            <a:ext cx="4023360" cy="493776"/>
           </a:xfrm>
           <a:prstGeom prst="roundRect">
             <a:avLst>
-              <a:gd name="adj" fmla="val 12308"/>
+              <a:gd name="adj" fmla="val 14815"/>
             </a:avLst>
           </a:prstGeom>
           <a:solidFill>
@@ -5526,12 +5747,12 @@
         </p:nvSpPr>
         <p:spPr>
           <a:xfrm>
-            <a:off x="4663440" y="2606040"/>
-            <a:ext cx="365760" cy="594360"/>
+            <a:off x="4663440" y="1682496"/>
+            <a:ext cx="347472" cy="493776"/>
           </a:xfrm>
           <a:prstGeom prst="roundRect">
             <a:avLst>
-              <a:gd name="adj" fmla="val 20000"/>
+              <a:gd name="adj" fmla="val 21053"/>
             </a:avLst>
           </a:prstGeom>
           <a:solidFill>
@@ -5553,8 +5774,8 @@
         </p:nvSpPr>
         <p:spPr>
           <a:xfrm>
-            <a:off x="4663440" y="2606040"/>
-            <a:ext cx="365760" cy="594360"/>
+            <a:off x="4663440" y="1682496"/>
+            <a:ext cx="347472" cy="493776"/>
           </a:xfrm>
           <a:prstGeom prst="rect">
             <a:avLst/>
@@ -5592,24 +5813,24 @@
         </p:nvSpPr>
         <p:spPr>
           <a:xfrm>
-            <a:off x="5102352" y="2642616"/>
-            <a:ext cx="2286000" cy="274320"/>
-          </a:xfrm>
-          <a:prstGeom prst="rect">
-            <a:avLst/>
-          </a:prstGeom>
-          <a:noFill/>
-          <a:ln/>
-        </p:spPr>
-        <p:txBody>
-          <a:bodyPr wrap="square" lIns="0" tIns="0" rIns="0" bIns="0" rtlCol="0" anchor="ctr"/>
-          <a:lstStyle/>
-          <a:p>
-            <a:pPr indent="0" marL="0">
-              <a:buNone/>
-            </a:pPr>
-            <a:r>
-              <a:rPr lang="en-US" sz="1050" b="1" dirty="0">
+            <a:off x="5084064" y="1709928"/>
+            <a:ext cx="2286000" cy="228600"/>
+          </a:xfrm>
+          <a:prstGeom prst="rect">
+            <a:avLst/>
+          </a:prstGeom>
+          <a:noFill/>
+          <a:ln/>
+        </p:spPr>
+        <p:txBody>
+          <a:bodyPr wrap="square" lIns="0" tIns="0" rIns="0" bIns="0" rtlCol="0" anchor="ctr"/>
+          <a:lstStyle/>
+          <a:p>
+            <a:pPr indent="0" marL="0">
+              <a:buNone/>
+            </a:pPr>
+            <a:r>
+              <a:rPr lang="en-US" sz="1000" b="1" dirty="0">
                 <a:solidFill>
                   <a:srgbClr val="1A1A18"/>
                 </a:solidFill>
@@ -5619,7 +5840,7 @@
               </a:rPr>
               <a:t>Symbol entities</a:t>
             </a:r>
-            <a:endParaRPr lang="en-US" sz="1050" dirty="0"/>
+            <a:endParaRPr lang="en-US" sz="1000" dirty="0"/>
           </a:p>
         </p:txBody>
       </p:sp>
@@ -5631,24 +5852,24 @@
         </p:nvSpPr>
         <p:spPr>
           <a:xfrm>
-            <a:off x="5102352" y="2898648"/>
-            <a:ext cx="3474720" cy="256032"/>
-          </a:xfrm>
-          <a:prstGeom prst="rect">
-            <a:avLst/>
-          </a:prstGeom>
-          <a:noFill/>
-          <a:ln/>
-        </p:spPr>
-        <p:txBody>
-          <a:bodyPr wrap="square" lIns="0" tIns="0" rIns="0" bIns="0" rtlCol="0" anchor="ctr"/>
-          <a:lstStyle/>
-          <a:p>
-            <a:pPr indent="0" marL="0">
-              <a:buNone/>
-            </a:pPr>
-            <a:r>
-              <a:rPr lang="en-US" sz="900" dirty="0">
+            <a:off x="5084064" y="1938528"/>
+            <a:ext cx="3474720" cy="201168"/>
+          </a:xfrm>
+          <a:prstGeom prst="rect">
+            <a:avLst/>
+          </a:prstGeom>
+          <a:noFill/>
+          <a:ln/>
+        </p:spPr>
+        <p:txBody>
+          <a:bodyPr wrap="square" lIns="0" tIns="0" rIns="0" bIns="0" rtlCol="0" anchor="ctr"/>
+          <a:lstStyle/>
+          <a:p>
+            <a:pPr indent="0" marL="0">
+              <a:buNone/>
+            </a:pPr>
+            <a:r>
+              <a:rPr lang="en-US" sz="850" dirty="0">
                 <a:solidFill>
                   <a:srgbClr val="5A5952"/>
                 </a:solidFill>
@@ -5658,7 +5879,7 @@
               </a:rPr>
               <a:t>(C)(TM)(R) → &amp;copy;&amp;trade;&amp;reg;</a:t>
             </a:r>
-            <a:endParaRPr lang="en-US" sz="900" dirty="0"/>
+            <a:endParaRPr lang="en-US" sz="850" dirty="0"/>
           </a:p>
         </p:txBody>
       </p:sp>
@@ -5670,12 +5891,12 @@
         </p:nvSpPr>
         <p:spPr>
           <a:xfrm>
-            <a:off x="4663440" y="3291840"/>
-            <a:ext cx="4023360" cy="594360"/>
+            <a:off x="4663440" y="2249424"/>
+            <a:ext cx="4023360" cy="493776"/>
           </a:xfrm>
           <a:prstGeom prst="roundRect">
             <a:avLst>
-              <a:gd name="adj" fmla="val 12308"/>
+              <a:gd name="adj" fmla="val 14815"/>
             </a:avLst>
           </a:prstGeom>
           <a:solidFill>
@@ -5704,12 +5925,12 @@
         </p:nvSpPr>
         <p:spPr>
           <a:xfrm>
-            <a:off x="4663440" y="3291840"/>
-            <a:ext cx="365760" cy="594360"/>
+            <a:off x="4663440" y="2249424"/>
+            <a:ext cx="347472" cy="493776"/>
           </a:xfrm>
           <a:prstGeom prst="roundRect">
             <a:avLst>
-              <a:gd name="adj" fmla="val 20000"/>
+              <a:gd name="adj" fmla="val 21053"/>
             </a:avLst>
           </a:prstGeom>
           <a:solidFill>
@@ -5731,8 +5952,8 @@
         </p:nvSpPr>
         <p:spPr>
           <a:xfrm>
-            <a:off x="4663440" y="3291840"/>
-            <a:ext cx="365760" cy="594360"/>
+            <a:off x="4663440" y="2249424"/>
+            <a:ext cx="347472" cy="493776"/>
           </a:xfrm>
           <a:prstGeom prst="rect">
             <a:avLst/>
@@ -5770,24 +5991,24 @@
         </p:nvSpPr>
         <p:spPr>
           <a:xfrm>
-            <a:off x="5102352" y="3328416"/>
-            <a:ext cx="2286000" cy="274320"/>
-          </a:xfrm>
-          <a:prstGeom prst="rect">
-            <a:avLst/>
-          </a:prstGeom>
-          <a:noFill/>
-          <a:ln/>
-        </p:spPr>
-        <p:txBody>
-          <a:bodyPr wrap="square" lIns="0" tIns="0" rIns="0" bIns="0" rtlCol="0" anchor="ctr"/>
-          <a:lstStyle/>
-          <a:p>
-            <a:pPr indent="0" marL="0">
-              <a:buNone/>
-            </a:pPr>
-            <a:r>
-              <a:rPr lang="en-US" sz="1050" b="1" dirty="0">
+            <a:off x="5084064" y="2276856"/>
+            <a:ext cx="2286000" cy="228600"/>
+          </a:xfrm>
+          <a:prstGeom prst="rect">
+            <a:avLst/>
+          </a:prstGeom>
+          <a:noFill/>
+          <a:ln/>
+        </p:spPr>
+        <p:txBody>
+          <a:bodyPr wrap="square" lIns="0" tIns="0" rIns="0" bIns="0" rtlCol="0" anchor="ctr"/>
+          <a:lstStyle/>
+          <a:p>
+            <a:pPr indent="0" marL="0">
+              <a:buNone/>
+            </a:pPr>
+            <a:r>
+              <a:rPr lang="en-US" sz="1000" b="1" dirty="0">
                 <a:solidFill>
                   <a:srgbClr val="1A1A18"/>
                 </a:solidFill>
@@ -5797,7 +6018,7 @@
               </a:rPr>
               <a:t>Table scope</a:t>
             </a:r>
-            <a:endParaRPr lang="en-US" sz="1050" dirty="0"/>
+            <a:endParaRPr lang="en-US" sz="1000" dirty="0"/>
           </a:p>
         </p:txBody>
       </p:sp>
@@ -5809,24 +6030,24 @@
         </p:nvSpPr>
         <p:spPr>
           <a:xfrm>
-            <a:off x="5102352" y="3584448"/>
-            <a:ext cx="3474720" cy="256032"/>
-          </a:xfrm>
-          <a:prstGeom prst="rect">
-            <a:avLst/>
-          </a:prstGeom>
-          <a:noFill/>
-          <a:ln/>
-        </p:spPr>
-        <p:txBody>
-          <a:bodyPr wrap="square" lIns="0" tIns="0" rIns="0" bIns="0" rtlCol="0" anchor="ctr"/>
-          <a:lstStyle/>
-          <a:p>
-            <a:pPr indent="0" marL="0">
-              <a:buNone/>
-            </a:pPr>
-            <a:r>
-              <a:rPr lang="en-US" sz="900" dirty="0">
+            <a:off x="5084064" y="2505456"/>
+            <a:ext cx="3474720" cy="201168"/>
+          </a:xfrm>
+          <a:prstGeom prst="rect">
+            <a:avLst/>
+          </a:prstGeom>
+          <a:noFill/>
+          <a:ln/>
+        </p:spPr>
+        <p:txBody>
+          <a:bodyPr wrap="square" lIns="0" tIns="0" rIns="0" bIns="0" rtlCol="0" anchor="ctr"/>
+          <a:lstStyle/>
+          <a:p>
+            <a:pPr indent="0" marL="0">
+              <a:buNone/>
+            </a:pPr>
+            <a:r>
+              <a:rPr lang="en-US" sz="850" dirty="0">
                 <a:solidFill>
                   <a:srgbClr val="5A5952"/>
                 </a:solidFill>
@@ -5836,7 +6057,7 @@
               </a:rPr>
               <a:t>Bold row → &lt;th scope="col"&gt;</a:t>
             </a:r>
-            <a:endParaRPr lang="en-US" sz="900" dirty="0"/>
+            <a:endParaRPr lang="en-US" sz="850" dirty="0"/>
           </a:p>
         </p:txBody>
       </p:sp>
@@ -5848,12 +6069,12 @@
         </p:nvSpPr>
         <p:spPr>
           <a:xfrm>
-            <a:off x="4663440" y="3977640"/>
-            <a:ext cx="4023360" cy="594360"/>
+            <a:off x="4663440" y="2816352"/>
+            <a:ext cx="4023360" cy="493776"/>
           </a:xfrm>
           <a:prstGeom prst="roundRect">
             <a:avLst>
-              <a:gd name="adj" fmla="val 12308"/>
+              <a:gd name="adj" fmla="val 14815"/>
             </a:avLst>
           </a:prstGeom>
           <a:solidFill>
@@ -5882,12 +6103,12 @@
         </p:nvSpPr>
         <p:spPr>
           <a:xfrm>
-            <a:off x="4663440" y="3977640"/>
-            <a:ext cx="365760" cy="594360"/>
+            <a:off x="4663440" y="2816352"/>
+            <a:ext cx="347472" cy="493776"/>
           </a:xfrm>
           <a:prstGeom prst="roundRect">
             <a:avLst>
-              <a:gd name="adj" fmla="val 20000"/>
+              <a:gd name="adj" fmla="val 21053"/>
             </a:avLst>
           </a:prstGeom>
           <a:solidFill>
@@ -5909,8 +6130,8 @@
         </p:nvSpPr>
         <p:spPr>
           <a:xfrm>
-            <a:off x="4663440" y="3977640"/>
-            <a:ext cx="365760" cy="594360"/>
+            <a:off x="4663440" y="2816352"/>
+            <a:ext cx="347472" cy="493776"/>
           </a:xfrm>
           <a:prstGeom prst="rect">
             <a:avLst/>
@@ -5948,24 +6169,24 @@
         </p:nvSpPr>
         <p:spPr>
           <a:xfrm>
-            <a:off x="5102352" y="4014216"/>
-            <a:ext cx="2286000" cy="274320"/>
-          </a:xfrm>
-          <a:prstGeom prst="rect">
-            <a:avLst/>
-          </a:prstGeom>
-          <a:noFill/>
-          <a:ln/>
-        </p:spPr>
-        <p:txBody>
-          <a:bodyPr wrap="square" lIns="0" tIns="0" rIns="0" bIns="0" rtlCol="0" anchor="ctr"/>
-          <a:lstStyle/>
-          <a:p>
-            <a:pPr indent="0" marL="0">
-              <a:buNone/>
-            </a:pPr>
-            <a:r>
-              <a:rPr lang="en-US" sz="1050" b="1" dirty="0">
+            <a:off x="5084064" y="2843784"/>
+            <a:ext cx="2286000" cy="228600"/>
+          </a:xfrm>
+          <a:prstGeom prst="rect">
+            <a:avLst/>
+          </a:prstGeom>
+          <a:noFill/>
+          <a:ln/>
+        </p:spPr>
+        <p:txBody>
+          <a:bodyPr wrap="square" lIns="0" tIns="0" rIns="0" bIns="0" rtlCol="0" anchor="ctr"/>
+          <a:lstStyle/>
+          <a:p>
+            <a:pPr indent="0" marL="0">
+              <a:buNone/>
+            </a:pPr>
+            <a:r>
+              <a:rPr lang="en-US" sz="1000" b="1" dirty="0">
                 <a:solidFill>
                   <a:srgbClr val="1A1A18"/>
                 </a:solidFill>
@@ -5975,7 +6196,7 @@
               </a:rPr>
               <a:t>Bluecard®</a:t>
             </a:r>
-            <a:endParaRPr lang="en-US" sz="1050" dirty="0"/>
+            <a:endParaRPr lang="en-US" sz="1000" dirty="0"/>
           </a:p>
         </p:txBody>
       </p:sp>
@@ -5987,24 +6208,24 @@
         </p:nvSpPr>
         <p:spPr>
           <a:xfrm>
-            <a:off x="5102352" y="4270248"/>
-            <a:ext cx="3474720" cy="256032"/>
-          </a:xfrm>
-          <a:prstGeom prst="rect">
-            <a:avLst/>
-          </a:prstGeom>
-          <a:noFill/>
-          <a:ln/>
-        </p:spPr>
-        <p:txBody>
-          <a:bodyPr wrap="square" lIns="0" tIns="0" rIns="0" bIns="0" rtlCol="0" anchor="ctr"/>
-          <a:lstStyle/>
-          <a:p>
-            <a:pPr indent="0" marL="0">
-              <a:buNone/>
-            </a:pPr>
-            <a:r>
-              <a:rPr lang="en-US" sz="900" dirty="0">
+            <a:off x="5084064" y="3072384"/>
+            <a:ext cx="3474720" cy="201168"/>
+          </a:xfrm>
+          <a:prstGeom prst="rect">
+            <a:avLst/>
+          </a:prstGeom>
+          <a:noFill/>
+          <a:ln/>
+        </p:spPr>
+        <p:txBody>
+          <a:bodyPr wrap="square" lIns="0" tIns="0" rIns="0" bIns="0" rtlCol="0" anchor="ctr"/>
+          <a:lstStyle/>
+          <a:p>
+            <a:pPr indent="0" marL="0">
+              <a:buNone/>
+            </a:pPr>
+            <a:r>
+              <a:rPr lang="en-US" sz="850" dirty="0">
                 <a:solidFill>
                   <a:srgbClr val="5A5952"/>
                 </a:solidFill>
@@ -6014,7 +6235,7 @@
               </a:rPr>
               <a:t>Bluecard → Bluecard&amp;reg;</a:t>
             </a:r>
-            <a:endParaRPr lang="en-US" sz="900" dirty="0"/>
+            <a:endParaRPr lang="en-US" sz="850" dirty="0"/>
           </a:p>
         </p:txBody>
       </p:sp>
@@ -6026,12 +6247,46 @@
         </p:nvSpPr>
         <p:spPr>
           <a:xfrm>
-            <a:off x="365760" y="4663440"/>
-            <a:ext cx="8412480" cy="320040"/>
+            <a:off x="4663440" y="3383280"/>
+            <a:ext cx="4023360" cy="493776"/>
           </a:xfrm>
           <a:prstGeom prst="roundRect">
             <a:avLst>
-              <a:gd name="adj" fmla="val 22857"/>
+              <a:gd name="adj" fmla="val 14815"/>
+            </a:avLst>
+          </a:prstGeom>
+          <a:solidFill>
+            <a:srgbClr val="FFFFFF"/>
+          </a:solidFill>
+          <a:ln w="12700">
+            <a:solidFill>
+              <a:srgbClr val="E2E0D8"/>
+            </a:solidFill>
+            <a:prstDash val="solid"/>
+          </a:ln>
+          <a:effectLst>
+            <a:outerShdw sx="100000" sy="100000" kx="0" ky="0" algn="bl" rotWithShape="0" blurRad="101600" dist="38100" dir="2700000">
+              <a:srgbClr val="000000">
+                <a:alpha val="10000"/>
+              </a:srgbClr>
+            </a:outerShdw>
+          </a:effectLst>
+        </p:spPr>
+      </p:sp>
+      <p:sp>
+        <p:nvSpPr>
+          <p:cNvPr id="55" name="Shape 53"/>
+          <p:cNvSpPr/>
+          <p:nvPr/>
+        </p:nvSpPr>
+        <p:spPr>
+          <a:xfrm>
+            <a:off x="4663440" y="3383280"/>
+            <a:ext cx="347472" cy="493776"/>
+          </a:xfrm>
+          <a:prstGeom prst="roundRect">
+            <a:avLst>
+              <a:gd name="adj" fmla="val 21053"/>
             </a:avLst>
           </a:prstGeom>
           <a:solidFill>
@@ -6047,40 +6302,362 @@
       </p:sp>
       <p:sp>
         <p:nvSpPr>
-          <p:cNvPr id="55" name="Text 53"/>
-          <p:cNvSpPr/>
-          <p:nvPr/>
-        </p:nvSpPr>
-        <p:spPr>
-          <a:xfrm>
-            <a:off x="457200" y="4663440"/>
-            <a:ext cx="8229600" cy="320040"/>
-          </a:xfrm>
-          <a:prstGeom prst="rect">
-            <a:avLst/>
-          </a:prstGeom>
-          <a:noFill/>
-          <a:ln/>
-        </p:spPr>
-        <p:txBody>
-          <a:bodyPr wrap="square" lIns="0" tIns="0" rIns="0" bIns="0" rtlCol="0" anchor="ctr"/>
-          <a:lstStyle/>
-          <a:p>
-            <a:pPr indent="0" marL="0">
-              <a:buNone/>
-            </a:pPr>
-            <a:r>
-              <a:rPr lang="en-US" sz="1000" dirty="0">
-                <a:solidFill>
-                  <a:srgbClr val="A8D5A2"/>
+          <p:cNvPr id="56" name="Text 54"/>
+          <p:cNvSpPr/>
+          <p:nvPr/>
+        </p:nvSpPr>
+        <p:spPr>
+          <a:xfrm>
+            <a:off x="4663440" y="3383280"/>
+            <a:ext cx="347472" cy="493776"/>
+          </a:xfrm>
+          <a:prstGeom prst="rect">
+            <a:avLst/>
+          </a:prstGeom>
+          <a:noFill/>
+          <a:ln/>
+        </p:spPr>
+        <p:txBody>
+          <a:bodyPr wrap="square" lIns="0" tIns="0" rIns="0" bIns="0" rtlCol="0" anchor="ctr"/>
+          <a:lstStyle/>
+          <a:p>
+            <a:pPr algn="ctr" indent="0" marL="0">
+              <a:buNone/>
+            </a:pPr>
+            <a:r>
+              <a:rPr lang="en-US" sz="800" b="1" dirty="0">
+                <a:solidFill>
+                  <a:srgbClr val="FFFFFF"/>
                 </a:solidFill>
                 <a:latin typeface="Courier New" pitchFamily="34" charset="0"/>
                 <a:ea typeface="Courier New" pitchFamily="34" charset="-122"/>
                 <a:cs typeface="Courier New" pitchFamily="34" charset="-120"/>
               </a:rPr>
-              <a:t>Rule 11 — &amp;nbsp; → regular space    |    Rule C — Consecutive &lt;strong&gt; merging: nested &amp; adjacent tags collapsed into one</a:t>
+              <a:t>11</a:t>
+            </a:r>
+            <a:endParaRPr lang="en-US" sz="800" dirty="0"/>
+          </a:p>
+        </p:txBody>
+      </p:sp>
+      <p:sp>
+        <p:nvSpPr>
+          <p:cNvPr id="57" name="Text 55"/>
+          <p:cNvSpPr/>
+          <p:nvPr/>
+        </p:nvSpPr>
+        <p:spPr>
+          <a:xfrm>
+            <a:off x="5084064" y="3410712"/>
+            <a:ext cx="2286000" cy="228600"/>
+          </a:xfrm>
+          <a:prstGeom prst="rect">
+            <a:avLst/>
+          </a:prstGeom>
+          <a:noFill/>
+          <a:ln/>
+        </p:spPr>
+        <p:txBody>
+          <a:bodyPr wrap="square" lIns="0" tIns="0" rIns="0" bIns="0" rtlCol="0" anchor="ctr"/>
+          <a:lstStyle/>
+          <a:p>
+            <a:pPr indent="0" marL="0">
+              <a:buNone/>
+            </a:pPr>
+            <a:r>
+              <a:rPr lang="en-US" sz="1000" b="1" dirty="0">
+                <a:solidFill>
+                  <a:srgbClr val="1A1A18"/>
+                </a:solidFill>
+                <a:latin typeface="Calibri" pitchFamily="34" charset="0"/>
+                <a:ea typeface="Calibri" pitchFamily="34" charset="-122"/>
+                <a:cs typeface="Calibri" pitchFamily="34" charset="-120"/>
+              </a:rPr>
+              <a:t>Remove &amp;nbsp;</a:t>
             </a:r>
             <a:endParaRPr lang="en-US" sz="1000" dirty="0"/>
+          </a:p>
+        </p:txBody>
+      </p:sp>
+      <p:sp>
+        <p:nvSpPr>
+          <p:cNvPr id="58" name="Text 56"/>
+          <p:cNvSpPr/>
+          <p:nvPr/>
+        </p:nvSpPr>
+        <p:spPr>
+          <a:xfrm>
+            <a:off x="5084064" y="3639312"/>
+            <a:ext cx="3474720" cy="201168"/>
+          </a:xfrm>
+          <a:prstGeom prst="rect">
+            <a:avLst/>
+          </a:prstGeom>
+          <a:noFill/>
+          <a:ln/>
+        </p:spPr>
+        <p:txBody>
+          <a:bodyPr wrap="square" lIns="0" tIns="0" rIns="0" bIns="0" rtlCol="0" anchor="ctr"/>
+          <a:lstStyle/>
+          <a:p>
+            <a:pPr indent="0" marL="0">
+              <a:buNone/>
+            </a:pPr>
+            <a:r>
+              <a:rPr lang="en-US" sz="850" dirty="0">
+                <a:solidFill>
+                  <a:srgbClr val="5A5952"/>
+                </a:solidFill>
+                <a:latin typeface="Courier New" pitchFamily="34" charset="0"/>
+                <a:ea typeface="Courier New" pitchFamily="34" charset="-122"/>
+                <a:cs typeface="Courier New" pitchFamily="34" charset="-120"/>
+              </a:rPr>
+              <a:t>&amp;nbsp; → regular space</a:t>
+            </a:r>
+            <a:endParaRPr lang="en-US" sz="850" dirty="0"/>
+          </a:p>
+        </p:txBody>
+      </p:sp>
+      <p:sp>
+        <p:nvSpPr>
+          <p:cNvPr id="59" name="Shape 57"/>
+          <p:cNvSpPr/>
+          <p:nvPr/>
+        </p:nvSpPr>
+        <p:spPr>
+          <a:xfrm>
+            <a:off x="4663440" y="3950208"/>
+            <a:ext cx="4023360" cy="493776"/>
+          </a:xfrm>
+          <a:prstGeom prst="roundRect">
+            <a:avLst>
+              <a:gd name="adj" fmla="val 14815"/>
+            </a:avLst>
+          </a:prstGeom>
+          <a:solidFill>
+            <a:srgbClr val="FFFFFF"/>
+          </a:solidFill>
+          <a:ln w="12700">
+            <a:solidFill>
+              <a:srgbClr val="E2E0D8"/>
+            </a:solidFill>
+            <a:prstDash val="solid"/>
+          </a:ln>
+          <a:effectLst>
+            <a:outerShdw sx="100000" sy="100000" kx="0" ky="0" algn="bl" rotWithShape="0" blurRad="101600" dist="38100" dir="2700000">
+              <a:srgbClr val="000000">
+                <a:alpha val="10000"/>
+              </a:srgbClr>
+            </a:outerShdw>
+          </a:effectLst>
+        </p:spPr>
+      </p:sp>
+      <p:sp>
+        <p:nvSpPr>
+          <p:cNvPr id="60" name="Shape 58"/>
+          <p:cNvSpPr/>
+          <p:nvPr/>
+        </p:nvSpPr>
+        <p:spPr>
+          <a:xfrm>
+            <a:off x="4663440" y="3950208"/>
+            <a:ext cx="347472" cy="493776"/>
+          </a:xfrm>
+          <a:prstGeom prst="roundRect">
+            <a:avLst>
+              <a:gd name="adj" fmla="val 21053"/>
+            </a:avLst>
+          </a:prstGeom>
+          <a:solidFill>
+            <a:srgbClr val="9B2C2C"/>
+          </a:solidFill>
+          <a:ln w="12700">
+            <a:solidFill>
+              <a:srgbClr val="9B2C2C"/>
+            </a:solidFill>
+            <a:prstDash val="solid"/>
+          </a:ln>
+        </p:spPr>
+      </p:sp>
+      <p:sp>
+        <p:nvSpPr>
+          <p:cNvPr id="61" name="Text 59"/>
+          <p:cNvSpPr/>
+          <p:nvPr/>
+        </p:nvSpPr>
+        <p:spPr>
+          <a:xfrm>
+            <a:off x="4663440" y="3950208"/>
+            <a:ext cx="347472" cy="493776"/>
+          </a:xfrm>
+          <a:prstGeom prst="rect">
+            <a:avLst/>
+          </a:prstGeom>
+          <a:noFill/>
+          <a:ln/>
+        </p:spPr>
+        <p:txBody>
+          <a:bodyPr wrap="square" lIns="0" tIns="0" rIns="0" bIns="0" rtlCol="0" anchor="ctr"/>
+          <a:lstStyle/>
+          <a:p>
+            <a:pPr algn="ctr" indent="0" marL="0">
+              <a:buNone/>
+            </a:pPr>
+            <a:r>
+              <a:rPr lang="en-US" sz="800" b="1" dirty="0">
+                <a:solidFill>
+                  <a:srgbClr val="FFFFFF"/>
+                </a:solidFill>
+                <a:latin typeface="Courier New" pitchFamily="34" charset="0"/>
+                <a:ea typeface="Courier New" pitchFamily="34" charset="-122"/>
+                <a:cs typeface="Courier New" pitchFamily="34" charset="-120"/>
+              </a:rPr>
+              <a:t>D</a:t>
+            </a:r>
+            <a:endParaRPr lang="en-US" sz="800" dirty="0"/>
+          </a:p>
+        </p:txBody>
+      </p:sp>
+      <p:sp>
+        <p:nvSpPr>
+          <p:cNvPr id="62" name="Text 60"/>
+          <p:cNvSpPr/>
+          <p:nvPr/>
+        </p:nvSpPr>
+        <p:spPr>
+          <a:xfrm>
+            <a:off x="5084064" y="3977640"/>
+            <a:ext cx="2286000" cy="228600"/>
+          </a:xfrm>
+          <a:prstGeom prst="rect">
+            <a:avLst/>
+          </a:prstGeom>
+          <a:noFill/>
+          <a:ln/>
+        </p:spPr>
+        <p:txBody>
+          <a:bodyPr wrap="square" lIns="0" tIns="0" rIns="0" bIns="0" rtlCol="0" anchor="ctr"/>
+          <a:lstStyle/>
+          <a:p>
+            <a:pPr indent="0" marL="0">
+              <a:buNone/>
+            </a:pPr>
+            <a:r>
+              <a:rPr lang="en-US" sz="1000" b="1" dirty="0">
+                <a:solidFill>
+                  <a:srgbClr val="1A1A18"/>
+                </a:solidFill>
+                <a:latin typeface="Calibri" pitchFamily="34" charset="0"/>
+                <a:ea typeface="Calibri" pitchFamily="34" charset="-122"/>
+                <a:cs typeface="Calibri" pitchFamily="34" charset="-120"/>
+              </a:rPr>
+              <a:t>Remove strikethrough</a:t>
+            </a:r>
+            <a:endParaRPr lang="en-US" sz="1000" dirty="0"/>
+          </a:p>
+        </p:txBody>
+      </p:sp>
+      <p:sp>
+        <p:nvSpPr>
+          <p:cNvPr id="63" name="Text 61"/>
+          <p:cNvSpPr/>
+          <p:nvPr/>
+        </p:nvSpPr>
+        <p:spPr>
+          <a:xfrm>
+            <a:off x="5084064" y="4206240"/>
+            <a:ext cx="3474720" cy="201168"/>
+          </a:xfrm>
+          <a:prstGeom prst="rect">
+            <a:avLst/>
+          </a:prstGeom>
+          <a:noFill/>
+          <a:ln/>
+        </p:spPr>
+        <p:txBody>
+          <a:bodyPr wrap="square" lIns="0" tIns="0" rIns="0" bIns="0" rtlCol="0" anchor="ctr"/>
+          <a:lstStyle/>
+          <a:p>
+            <a:pPr indent="0" marL="0">
+              <a:buNone/>
+            </a:pPr>
+            <a:r>
+              <a:rPr lang="en-US" sz="850" dirty="0">
+                <a:solidFill>
+                  <a:srgbClr val="5A5952"/>
+                </a:solidFill>
+                <a:latin typeface="Courier New" pitchFamily="34" charset="0"/>
+                <a:ea typeface="Courier New" pitchFamily="34" charset="-122"/>
+                <a:cs typeface="Courier New" pitchFamily="34" charset="-120"/>
+              </a:rPr>
+              <a:t>&lt;s&gt;/&lt;del&gt;/~~text~~ and content removed</a:t>
+            </a:r>
+            <a:endParaRPr lang="en-US" sz="850" dirty="0"/>
+          </a:p>
+        </p:txBody>
+      </p:sp>
+      <p:sp>
+        <p:nvSpPr>
+          <p:cNvPr id="64" name="Shape 62"/>
+          <p:cNvSpPr/>
+          <p:nvPr/>
+        </p:nvSpPr>
+        <p:spPr>
+          <a:xfrm>
+            <a:off x="365760" y="4663440"/>
+            <a:ext cx="8412480" cy="329184"/>
+          </a:xfrm>
+          <a:prstGeom prst="roundRect">
+            <a:avLst>
+              <a:gd name="adj" fmla="val 22222"/>
+            </a:avLst>
+          </a:prstGeom>
+          <a:solidFill>
+            <a:srgbClr val="1A1A18"/>
+          </a:solidFill>
+          <a:ln w="12700">
+            <a:solidFill>
+              <a:srgbClr val="1A1A18"/>
+            </a:solidFill>
+            <a:prstDash val="solid"/>
+          </a:ln>
+        </p:spPr>
+      </p:sp>
+      <p:sp>
+        <p:nvSpPr>
+          <p:cNvPr id="65" name="Text 63"/>
+          <p:cNvSpPr/>
+          <p:nvPr/>
+        </p:nvSpPr>
+        <p:spPr>
+          <a:xfrm>
+            <a:off x="457200" y="4663440"/>
+            <a:ext cx="8229600" cy="329184"/>
+          </a:xfrm>
+          <a:prstGeom prst="rect">
+            <a:avLst/>
+          </a:prstGeom>
+          <a:noFill/>
+          <a:ln/>
+        </p:spPr>
+        <p:txBody>
+          <a:bodyPr wrap="square" lIns="0" tIns="0" rIns="0" bIns="0" rtlCol="0" anchor="ctr"/>
+          <a:lstStyle/>
+          <a:p>
+            <a:pPr indent="0" marL="0">
+              <a:buNone/>
+            </a:pPr>
+            <a:r>
+              <a:rPr lang="en-US" sz="850" dirty="0">
+                <a:solidFill>
+                  <a:srgbClr val="A8D5A2"/>
+                </a:solidFill>
+                <a:latin typeface="Courier New" pitchFamily="34" charset="0"/>
+                <a:ea typeface="Courier New" pitchFamily="34" charset="-122"/>
+                <a:cs typeface="Courier New" pitchFamily="34" charset="-120"/>
+              </a:rPr>
+              <a:t>Rule E — &lt;strong&gt; wraps &lt;a&gt;    |    Rule C — Adjacent/nested &lt;strong&gt; merged    |    Rule F — file:// URLs fixed to https://</a:t>
+            </a:r>
+            <a:endParaRPr lang="en-US" sz="850" dirty="0"/>
           </a:p>
         </p:txBody>
       </p:sp>
@@ -8652,6 +9229,1020 @@
         </p:nvSpPr>
         <p:spPr>
           <a:xfrm>
+            <a:off x="457200" y="256032"/>
+            <a:ext cx="8229600" cy="457200"/>
+          </a:xfrm>
+          <a:prstGeom prst="rect">
+            <a:avLst/>
+          </a:prstGeom>
+          <a:noFill/>
+          <a:ln/>
+        </p:spPr>
+        <p:txBody>
+          <a:bodyPr wrap="square" lIns="0" tIns="0" rIns="0" bIns="0" rtlCol="0" anchor="ctr"/>
+          <a:lstStyle/>
+          <a:p>
+            <a:pPr indent="0" marL="0">
+              <a:buNone/>
+            </a:pPr>
+            <a:r>
+              <a:rPr lang="en-US" sz="2600" b="1" dirty="0">
+                <a:solidFill>
+                  <a:srgbClr val="1A1A18"/>
+                </a:solidFill>
+                <a:latin typeface="Calibri" pitchFamily="34" charset="0"/>
+                <a:ea typeface="Calibri" pitchFamily="34" charset="-122"/>
+                <a:cs typeface="Calibri" pitchFamily="34" charset="-120"/>
+              </a:rPr>
+              <a:t>Three New Rules: D, E &amp; F</a:t>
+            </a:r>
+            <a:endParaRPr lang="en-US" sz="2600" dirty="0"/>
+          </a:p>
+        </p:txBody>
+      </p:sp>
+      <p:sp>
+        <p:nvSpPr>
+          <p:cNvPr id="3" name="Shape 1"/>
+          <p:cNvSpPr/>
+          <p:nvPr/>
+        </p:nvSpPr>
+        <p:spPr>
+          <a:xfrm>
+            <a:off x="365760" y="804672"/>
+            <a:ext cx="8412480" cy="1371600"/>
+          </a:xfrm>
+          <a:prstGeom prst="roundRect">
+            <a:avLst>
+              <a:gd name="adj" fmla="val 6667"/>
+            </a:avLst>
+          </a:prstGeom>
+          <a:solidFill>
+            <a:srgbClr val="FFF0F0"/>
+          </a:solidFill>
+          <a:ln w="19050">
+            <a:solidFill>
+              <a:srgbClr val="F4CCCC"/>
+            </a:solidFill>
+            <a:prstDash val="solid"/>
+          </a:ln>
+        </p:spPr>
+      </p:sp>
+      <p:sp>
+        <p:nvSpPr>
+          <p:cNvPr id="4" name="Shape 2"/>
+          <p:cNvSpPr/>
+          <p:nvPr/>
+        </p:nvSpPr>
+        <p:spPr>
+          <a:xfrm>
+            <a:off x="365760" y="804672"/>
+            <a:ext cx="457200" cy="1371600"/>
+          </a:xfrm>
+          <a:prstGeom prst="roundRect">
+            <a:avLst>
+              <a:gd name="adj" fmla="val 20000"/>
+            </a:avLst>
+          </a:prstGeom>
+          <a:solidFill>
+            <a:srgbClr val="9B2C2C"/>
+          </a:solidFill>
+          <a:ln w="12700">
+            <a:solidFill>
+              <a:srgbClr val="9B2C2C"/>
+            </a:solidFill>
+            <a:prstDash val="solid"/>
+          </a:ln>
+        </p:spPr>
+      </p:sp>
+      <p:sp>
+        <p:nvSpPr>
+          <p:cNvPr id="5" name="Text 3"/>
+          <p:cNvSpPr/>
+          <p:nvPr/>
+        </p:nvSpPr>
+        <p:spPr>
+          <a:xfrm>
+            <a:off x="365760" y="804672"/>
+            <a:ext cx="457200" cy="1371600"/>
+          </a:xfrm>
+          <a:prstGeom prst="rect">
+            <a:avLst/>
+          </a:prstGeom>
+          <a:noFill/>
+          <a:ln/>
+        </p:spPr>
+        <p:txBody>
+          <a:bodyPr wrap="square" lIns="0" tIns="0" rIns="0" bIns="0" rtlCol="0" anchor="ctr"/>
+          <a:lstStyle/>
+          <a:p>
+            <a:pPr algn="ctr" indent="0" marL="0">
+              <a:buNone/>
+            </a:pPr>
+            <a:r>
+              <a:rPr lang="en-US" sz="1400" b="1" dirty="0">
+                <a:solidFill>
+                  <a:srgbClr val="FFFFFF"/>
+                </a:solidFill>
+                <a:latin typeface="Courier New" pitchFamily="34" charset="0"/>
+                <a:ea typeface="Courier New" pitchFamily="34" charset="-122"/>
+                <a:cs typeface="Courier New" pitchFamily="34" charset="-120"/>
+              </a:rPr>
+              <a:t>D</a:t>
+            </a:r>
+            <a:endParaRPr lang="en-US" sz="1400" dirty="0"/>
+          </a:p>
+        </p:txBody>
+      </p:sp>
+      <p:sp>
+        <p:nvSpPr>
+          <p:cNvPr id="6" name="Text 4"/>
+          <p:cNvSpPr/>
+          <p:nvPr/>
+        </p:nvSpPr>
+        <p:spPr>
+          <a:xfrm>
+            <a:off x="960120" y="850392"/>
+            <a:ext cx="3657600" cy="292608"/>
+          </a:xfrm>
+          <a:prstGeom prst="rect">
+            <a:avLst/>
+          </a:prstGeom>
+          <a:noFill/>
+          <a:ln/>
+        </p:spPr>
+        <p:txBody>
+          <a:bodyPr wrap="square" lIns="0" tIns="0" rIns="0" bIns="0" rtlCol="0" anchor="ctr"/>
+          <a:lstStyle/>
+          <a:p>
+            <a:pPr indent="0" marL="0">
+              <a:buNone/>
+            </a:pPr>
+            <a:r>
+              <a:rPr lang="en-US" sz="1300" b="1" dirty="0">
+                <a:solidFill>
+                  <a:srgbClr val="9B2C2C"/>
+                </a:solidFill>
+                <a:latin typeface="Calibri" pitchFamily="34" charset="0"/>
+                <a:ea typeface="Calibri" pitchFamily="34" charset="-122"/>
+                <a:cs typeface="Calibri" pitchFamily="34" charset="-120"/>
+              </a:rPr>
+              <a:t>Remove Strikethrough Text</a:t>
+            </a:r>
+            <a:endParaRPr lang="en-US" sz="1300" dirty="0"/>
+          </a:p>
+        </p:txBody>
+      </p:sp>
+      <p:sp>
+        <p:nvSpPr>
+          <p:cNvPr id="7" name="Text 5"/>
+          <p:cNvSpPr/>
+          <p:nvPr/>
+        </p:nvSpPr>
+        <p:spPr>
+          <a:xfrm>
+            <a:off x="960120" y="1143000"/>
+            <a:ext cx="7589520" cy="256032"/>
+          </a:xfrm>
+          <a:prstGeom prst="rect">
+            <a:avLst/>
+          </a:prstGeom>
+          <a:noFill/>
+          <a:ln/>
+        </p:spPr>
+        <p:txBody>
+          <a:bodyPr wrap="square" lIns="0" tIns="0" rIns="0" bIns="0" rtlCol="0" anchor="ctr"/>
+          <a:lstStyle/>
+          <a:p>
+            <a:pPr indent="0" marL="0">
+              <a:buNone/>
+            </a:pPr>
+            <a:r>
+              <a:rPr lang="en-US" sz="1050" dirty="0">
+                <a:solidFill>
+                  <a:srgbClr val="5A5952"/>
+                </a:solidFill>
+                <a:latin typeface="Calibri" pitchFamily="34" charset="0"/>
+                <a:ea typeface="Calibri" pitchFamily="34" charset="-122"/>
+                <a:cs typeface="Calibri" pitchFamily="34" charset="-120"/>
+              </a:rPr>
+              <a:t>Tags AND their text content are deleted entirely — not just unstyled.</a:t>
+            </a:r>
+            <a:endParaRPr lang="en-US" sz="1050" dirty="0"/>
+          </a:p>
+        </p:txBody>
+      </p:sp>
+      <p:sp>
+        <p:nvSpPr>
+          <p:cNvPr id="8" name="Shape 6"/>
+          <p:cNvSpPr/>
+          <p:nvPr/>
+        </p:nvSpPr>
+        <p:spPr>
+          <a:xfrm>
+            <a:off x="960120" y="1417320"/>
+            <a:ext cx="3474720" cy="594360"/>
+          </a:xfrm>
+          <a:prstGeom prst="roundRect">
+            <a:avLst>
+              <a:gd name="adj" fmla="val 10769"/>
+            </a:avLst>
+          </a:prstGeom>
+          <a:solidFill>
+            <a:srgbClr val="1A1A18"/>
+          </a:solidFill>
+          <a:ln w="12700">
+            <a:solidFill>
+              <a:srgbClr val="1A1A18"/>
+            </a:solidFill>
+            <a:prstDash val="solid"/>
+          </a:ln>
+        </p:spPr>
+      </p:sp>
+      <p:sp>
+        <p:nvSpPr>
+          <p:cNvPr id="9" name="Text 7"/>
+          <p:cNvSpPr/>
+          <p:nvPr/>
+        </p:nvSpPr>
+        <p:spPr>
+          <a:xfrm>
+            <a:off x="1051560" y="1444752"/>
+            <a:ext cx="3291840" cy="530352"/>
+          </a:xfrm>
+          <a:prstGeom prst="rect">
+            <a:avLst/>
+          </a:prstGeom>
+          <a:noFill/>
+          <a:ln/>
+        </p:spPr>
+        <p:txBody>
+          <a:bodyPr wrap="square" lIns="0" tIns="0" rIns="0" bIns="0" rtlCol="0" anchor="ctr"/>
+          <a:lstStyle/>
+          <a:p>
+            <a:pPr indent="0" marL="0">
+              <a:buNone/>
+            </a:pPr>
+            <a:r>
+              <a:rPr lang="en-US" sz="850" dirty="0">
+                <a:solidFill>
+                  <a:srgbClr val="F87171"/>
+                </a:solidFill>
+                <a:latin typeface="Courier New" pitchFamily="34" charset="0"/>
+                <a:ea typeface="Courier New" pitchFamily="34" charset="-122"/>
+                <a:cs typeface="Courier New" pitchFamily="34" charset="-120"/>
+              </a:rPr>
+              <a:t>Input:   &lt;s&gt;discontinued&lt;/s&gt; product</a:t>
+            </a:r>
+            <a:endParaRPr lang="en-US" sz="850" dirty="0"/>
+          </a:p>
+          <a:p>
+            <a:pPr indent="0" marL="0">
+              <a:buNone/>
+            </a:pPr>
+            <a:r>
+              <a:rPr lang="en-US" sz="850" dirty="0">
+                <a:solidFill>
+                  <a:srgbClr val="F87171"/>
+                </a:solidFill>
+                <a:latin typeface="Courier New" pitchFamily="34" charset="0"/>
+                <a:ea typeface="Courier New" pitchFamily="34" charset="-122"/>
+                <a:cs typeface="Courier New" pitchFamily="34" charset="-120"/>
+              </a:rPr>
+              <a:t>         ~~removed feature~~</a:t>
+            </a:r>
+            <a:endParaRPr lang="en-US" sz="850" dirty="0"/>
+          </a:p>
+        </p:txBody>
+      </p:sp>
+      <p:sp>
+        <p:nvSpPr>
+          <p:cNvPr id="10" name="Shape 8"/>
+          <p:cNvSpPr/>
+          <p:nvPr/>
+        </p:nvSpPr>
+        <p:spPr>
+          <a:xfrm>
+            <a:off x="4709160" y="1417320"/>
+            <a:ext cx="3886200" cy="594360"/>
+          </a:xfrm>
+          <a:prstGeom prst="roundRect">
+            <a:avLst>
+              <a:gd name="adj" fmla="val 10769"/>
+            </a:avLst>
+          </a:prstGeom>
+          <a:solidFill>
+            <a:srgbClr val="1A1A18"/>
+          </a:solidFill>
+          <a:ln w="12700">
+            <a:solidFill>
+              <a:srgbClr val="1A1A18"/>
+            </a:solidFill>
+            <a:prstDash val="solid"/>
+          </a:ln>
+        </p:spPr>
+      </p:sp>
+      <p:sp>
+        <p:nvSpPr>
+          <p:cNvPr id="11" name="Text 9"/>
+          <p:cNvSpPr/>
+          <p:nvPr/>
+        </p:nvSpPr>
+        <p:spPr>
+          <a:xfrm>
+            <a:off x="4800600" y="1444752"/>
+            <a:ext cx="3703320" cy="530352"/>
+          </a:xfrm>
+          <a:prstGeom prst="rect">
+            <a:avLst/>
+          </a:prstGeom>
+          <a:noFill/>
+          <a:ln/>
+        </p:spPr>
+        <p:txBody>
+          <a:bodyPr wrap="square" lIns="0" tIns="0" rIns="0" bIns="0" rtlCol="0" anchor="ctr"/>
+          <a:lstStyle/>
+          <a:p>
+            <a:pPr indent="0" marL="0">
+              <a:buNone/>
+            </a:pPr>
+            <a:r>
+              <a:rPr lang="en-US" sz="850" dirty="0">
+                <a:solidFill>
+                  <a:srgbClr val="A8D5A2"/>
+                </a:solidFill>
+                <a:latin typeface="Courier New" pitchFamily="34" charset="0"/>
+                <a:ea typeface="Courier New" pitchFamily="34" charset="-122"/>
+                <a:cs typeface="Courier New" pitchFamily="34" charset="-120"/>
+              </a:rPr>
+              <a:t>Output:  product</a:t>
+            </a:r>
+            <a:endParaRPr lang="en-US" sz="850" dirty="0"/>
+          </a:p>
+          <a:p>
+            <a:pPr indent="0" marL="0">
+              <a:buNone/>
+            </a:pPr>
+            <a:r>
+              <a:rPr lang="en-US" sz="850" dirty="0">
+                <a:solidFill>
+                  <a:srgbClr val="A8D5A2"/>
+                </a:solidFill>
+                <a:latin typeface="Courier New" pitchFamily="34" charset="0"/>
+                <a:ea typeface="Courier New" pitchFamily="34" charset="-122"/>
+                <a:cs typeface="Courier New" pitchFamily="34" charset="-120"/>
+              </a:rPr>
+              <a:t>         (text removed)</a:t>
+            </a:r>
+            <a:endParaRPr lang="en-US" sz="850" dirty="0"/>
+          </a:p>
+        </p:txBody>
+      </p:sp>
+      <p:sp>
+        <p:nvSpPr>
+          <p:cNvPr id="12" name="Shape 10"/>
+          <p:cNvSpPr/>
+          <p:nvPr/>
+        </p:nvSpPr>
+        <p:spPr>
+          <a:xfrm>
+            <a:off x="365760" y="2240280"/>
+            <a:ext cx="8412480" cy="1371600"/>
+          </a:xfrm>
+          <a:prstGeom prst="roundRect">
+            <a:avLst>
+              <a:gd name="adj" fmla="val 6667"/>
+            </a:avLst>
+          </a:prstGeom>
+          <a:solidFill>
+            <a:srgbClr val="F3EEFB"/>
+          </a:solidFill>
+          <a:ln w="19050">
+            <a:solidFill>
+              <a:srgbClr val="D4B8F5"/>
+            </a:solidFill>
+            <a:prstDash val="solid"/>
+          </a:ln>
+        </p:spPr>
+      </p:sp>
+      <p:sp>
+        <p:nvSpPr>
+          <p:cNvPr id="13" name="Shape 11"/>
+          <p:cNvSpPr/>
+          <p:nvPr/>
+        </p:nvSpPr>
+        <p:spPr>
+          <a:xfrm>
+            <a:off x="365760" y="2240280"/>
+            <a:ext cx="457200" cy="1371600"/>
+          </a:xfrm>
+          <a:prstGeom prst="roundRect">
+            <a:avLst>
+              <a:gd name="adj" fmla="val 20000"/>
+            </a:avLst>
+          </a:prstGeom>
+          <a:solidFill>
+            <a:srgbClr val="6B3FA0"/>
+          </a:solidFill>
+          <a:ln w="12700">
+            <a:solidFill>
+              <a:srgbClr val="6B3FA0"/>
+            </a:solidFill>
+            <a:prstDash val="solid"/>
+          </a:ln>
+        </p:spPr>
+      </p:sp>
+      <p:sp>
+        <p:nvSpPr>
+          <p:cNvPr id="14" name="Text 12"/>
+          <p:cNvSpPr/>
+          <p:nvPr/>
+        </p:nvSpPr>
+        <p:spPr>
+          <a:xfrm>
+            <a:off x="365760" y="2240280"/>
+            <a:ext cx="457200" cy="1371600"/>
+          </a:xfrm>
+          <a:prstGeom prst="rect">
+            <a:avLst/>
+          </a:prstGeom>
+          <a:noFill/>
+          <a:ln/>
+        </p:spPr>
+        <p:txBody>
+          <a:bodyPr wrap="square" lIns="0" tIns="0" rIns="0" bIns="0" rtlCol="0" anchor="ctr"/>
+          <a:lstStyle/>
+          <a:p>
+            <a:pPr algn="ctr" indent="0" marL="0">
+              <a:buNone/>
+            </a:pPr>
+            <a:r>
+              <a:rPr lang="en-US" sz="1400" b="1" dirty="0">
+                <a:solidFill>
+                  <a:srgbClr val="FFFFFF"/>
+                </a:solidFill>
+                <a:latin typeface="Courier New" pitchFamily="34" charset="0"/>
+                <a:ea typeface="Courier New" pitchFamily="34" charset="-122"/>
+                <a:cs typeface="Courier New" pitchFamily="34" charset="-120"/>
+              </a:rPr>
+              <a:t>E</a:t>
+            </a:r>
+            <a:endParaRPr lang="en-US" sz="1400" dirty="0"/>
+          </a:p>
+        </p:txBody>
+      </p:sp>
+      <p:sp>
+        <p:nvSpPr>
+          <p:cNvPr id="15" name="Text 13"/>
+          <p:cNvSpPr/>
+          <p:nvPr/>
+        </p:nvSpPr>
+        <p:spPr>
+          <a:xfrm>
+            <a:off x="960120" y="2286000"/>
+            <a:ext cx="4572000" cy="292608"/>
+          </a:xfrm>
+          <a:prstGeom prst="rect">
+            <a:avLst/>
+          </a:prstGeom>
+          <a:noFill/>
+          <a:ln/>
+        </p:spPr>
+        <p:txBody>
+          <a:bodyPr wrap="square" lIns="0" tIns="0" rIns="0" bIns="0" rtlCol="0" anchor="ctr"/>
+          <a:lstStyle/>
+          <a:p>
+            <a:pPr indent="0" marL="0">
+              <a:buNone/>
+            </a:pPr>
+            <a:r>
+              <a:rPr lang="en-US" sz="1300" b="1" dirty="0">
+                <a:solidFill>
+                  <a:srgbClr val="6B3FA0"/>
+                </a:solidFill>
+                <a:latin typeface="Calibri" pitchFamily="34" charset="0"/>
+                <a:ea typeface="Calibri" pitchFamily="34" charset="-122"/>
+                <a:cs typeface="Calibri" pitchFamily="34" charset="-120"/>
+              </a:rPr>
+              <a:t>&lt;strong&gt; Always Wraps &lt;a&gt;</a:t>
+            </a:r>
+            <a:endParaRPr lang="en-US" sz="1300" dirty="0"/>
+          </a:p>
+        </p:txBody>
+      </p:sp>
+      <p:sp>
+        <p:nvSpPr>
+          <p:cNvPr id="16" name="Text 14"/>
+          <p:cNvSpPr/>
+          <p:nvPr/>
+        </p:nvSpPr>
+        <p:spPr>
+          <a:xfrm>
+            <a:off x="960120" y="2578608"/>
+            <a:ext cx="7589520" cy="256032"/>
+          </a:xfrm>
+          <a:prstGeom prst="rect">
+            <a:avLst/>
+          </a:prstGeom>
+          <a:noFill/>
+          <a:ln/>
+        </p:spPr>
+        <p:txBody>
+          <a:bodyPr wrap="square" lIns="0" tIns="0" rIns="0" bIns="0" rtlCol="0" anchor="ctr"/>
+          <a:lstStyle/>
+          <a:p>
+            <a:pPr indent="0" marL="0">
+              <a:buNone/>
+            </a:pPr>
+            <a:r>
+              <a:rPr lang="en-US" sz="1050" dirty="0">
+                <a:solidFill>
+                  <a:srgbClr val="5A5952"/>
+                </a:solidFill>
+                <a:latin typeface="Calibri" pitchFamily="34" charset="0"/>
+                <a:ea typeface="Calibri" pitchFamily="34" charset="-122"/>
+                <a:cs typeface="Calibri" pitchFamily="34" charset="-120"/>
+              </a:rPr>
+              <a:t>Correct nesting order: the bold element contains the link, not the other way around.</a:t>
+            </a:r>
+            <a:endParaRPr lang="en-US" sz="1050" dirty="0"/>
+          </a:p>
+        </p:txBody>
+      </p:sp>
+      <p:sp>
+        <p:nvSpPr>
+          <p:cNvPr id="17" name="Shape 15"/>
+          <p:cNvSpPr/>
+          <p:nvPr/>
+        </p:nvSpPr>
+        <p:spPr>
+          <a:xfrm>
+            <a:off x="960120" y="2852928"/>
+            <a:ext cx="3474720" cy="594360"/>
+          </a:xfrm>
+          <a:prstGeom prst="roundRect">
+            <a:avLst>
+              <a:gd name="adj" fmla="val 10769"/>
+            </a:avLst>
+          </a:prstGeom>
+          <a:solidFill>
+            <a:srgbClr val="1A1A18"/>
+          </a:solidFill>
+          <a:ln w="12700">
+            <a:solidFill>
+              <a:srgbClr val="1A1A18"/>
+            </a:solidFill>
+            <a:prstDash val="solid"/>
+          </a:ln>
+        </p:spPr>
+      </p:sp>
+      <p:sp>
+        <p:nvSpPr>
+          <p:cNvPr id="18" name="Text 16"/>
+          <p:cNvSpPr/>
+          <p:nvPr/>
+        </p:nvSpPr>
+        <p:spPr>
+          <a:xfrm>
+            <a:off x="1051560" y="2880360"/>
+            <a:ext cx="3291840" cy="530352"/>
+          </a:xfrm>
+          <a:prstGeom prst="rect">
+            <a:avLst/>
+          </a:prstGeom>
+          <a:noFill/>
+          <a:ln/>
+        </p:spPr>
+        <p:txBody>
+          <a:bodyPr wrap="square" lIns="0" tIns="0" rIns="0" bIns="0" rtlCol="0" anchor="ctr"/>
+          <a:lstStyle/>
+          <a:p>
+            <a:pPr indent="0" marL="0">
+              <a:buNone/>
+            </a:pPr>
+            <a:r>
+              <a:rPr lang="en-US" sz="850" dirty="0">
+                <a:solidFill>
+                  <a:srgbClr val="F87171"/>
+                </a:solidFill>
+                <a:latin typeface="Courier New" pitchFamily="34" charset="0"/>
+                <a:ea typeface="Courier New" pitchFamily="34" charset="-122"/>
+                <a:cs typeface="Courier New" pitchFamily="34" charset="-120"/>
+              </a:rPr>
+              <a:t>✗  &lt;a href="..."&gt;&lt;strong&gt;Link&lt;/strong&gt;&lt;/a&gt;</a:t>
+            </a:r>
+            <a:endParaRPr lang="en-US" sz="850" dirty="0"/>
+          </a:p>
+        </p:txBody>
+      </p:sp>
+      <p:sp>
+        <p:nvSpPr>
+          <p:cNvPr id="19" name="Shape 17"/>
+          <p:cNvSpPr/>
+          <p:nvPr/>
+        </p:nvSpPr>
+        <p:spPr>
+          <a:xfrm>
+            <a:off x="4709160" y="2852928"/>
+            <a:ext cx="3886200" cy="594360"/>
+          </a:xfrm>
+          <a:prstGeom prst="roundRect">
+            <a:avLst>
+              <a:gd name="adj" fmla="val 10769"/>
+            </a:avLst>
+          </a:prstGeom>
+          <a:solidFill>
+            <a:srgbClr val="1A1A18"/>
+          </a:solidFill>
+          <a:ln w="12700">
+            <a:solidFill>
+              <a:srgbClr val="1A1A18"/>
+            </a:solidFill>
+            <a:prstDash val="solid"/>
+          </a:ln>
+        </p:spPr>
+      </p:sp>
+      <p:sp>
+        <p:nvSpPr>
+          <p:cNvPr id="20" name="Text 18"/>
+          <p:cNvSpPr/>
+          <p:nvPr/>
+        </p:nvSpPr>
+        <p:spPr>
+          <a:xfrm>
+            <a:off x="4800600" y="2880360"/>
+            <a:ext cx="3703320" cy="530352"/>
+          </a:xfrm>
+          <a:prstGeom prst="rect">
+            <a:avLst/>
+          </a:prstGeom>
+          <a:noFill/>
+          <a:ln/>
+        </p:spPr>
+        <p:txBody>
+          <a:bodyPr wrap="square" lIns="0" tIns="0" rIns="0" bIns="0" rtlCol="0" anchor="ctr"/>
+          <a:lstStyle/>
+          <a:p>
+            <a:pPr indent="0" marL="0">
+              <a:buNone/>
+            </a:pPr>
+            <a:r>
+              <a:rPr lang="en-US" sz="850" dirty="0">
+                <a:solidFill>
+                  <a:srgbClr val="A8D5A2"/>
+                </a:solidFill>
+                <a:latin typeface="Courier New" pitchFamily="34" charset="0"/>
+                <a:ea typeface="Courier New" pitchFamily="34" charset="-122"/>
+                <a:cs typeface="Courier New" pitchFamily="34" charset="-120"/>
+              </a:rPr>
+              <a:t>✓  &lt;strong&gt;&lt;a href="..."&gt;Link&lt;/a&gt;&lt;/strong&gt;</a:t>
+            </a:r>
+            <a:endParaRPr lang="en-US" sz="850" dirty="0"/>
+          </a:p>
+        </p:txBody>
+      </p:sp>
+      <p:sp>
+        <p:nvSpPr>
+          <p:cNvPr id="21" name="Shape 19"/>
+          <p:cNvSpPr/>
+          <p:nvPr/>
+        </p:nvSpPr>
+        <p:spPr>
+          <a:xfrm>
+            <a:off x="365760" y="3675888"/>
+            <a:ext cx="8412480" cy="1234440"/>
+          </a:xfrm>
+          <a:prstGeom prst="roundRect">
+            <a:avLst>
+              <a:gd name="adj" fmla="val 7407"/>
+            </a:avLst>
+          </a:prstGeom>
+          <a:solidFill>
+            <a:srgbClr val="FFF8EE"/>
+          </a:solidFill>
+          <a:ln w="19050">
+            <a:solidFill>
+              <a:srgbClr val="FBBF7A"/>
+            </a:solidFill>
+            <a:prstDash val="solid"/>
+          </a:ln>
+        </p:spPr>
+      </p:sp>
+      <p:sp>
+        <p:nvSpPr>
+          <p:cNvPr id="22" name="Shape 20"/>
+          <p:cNvSpPr/>
+          <p:nvPr/>
+        </p:nvSpPr>
+        <p:spPr>
+          <a:xfrm>
+            <a:off x="365760" y="3675888"/>
+            <a:ext cx="457200" cy="1234440"/>
+          </a:xfrm>
+          <a:prstGeom prst="roundRect">
+            <a:avLst>
+              <a:gd name="adj" fmla="val 20000"/>
+            </a:avLst>
+          </a:prstGeom>
+          <a:solidFill>
+            <a:srgbClr val="D97706"/>
+          </a:solidFill>
+          <a:ln w="12700">
+            <a:solidFill>
+              <a:srgbClr val="D97706"/>
+            </a:solidFill>
+            <a:prstDash val="solid"/>
+          </a:ln>
+        </p:spPr>
+      </p:sp>
+      <p:sp>
+        <p:nvSpPr>
+          <p:cNvPr id="23" name="Text 21"/>
+          <p:cNvSpPr/>
+          <p:nvPr/>
+        </p:nvSpPr>
+        <p:spPr>
+          <a:xfrm>
+            <a:off x="365760" y="3675888"/>
+            <a:ext cx="457200" cy="1234440"/>
+          </a:xfrm>
+          <a:prstGeom prst="rect">
+            <a:avLst/>
+          </a:prstGeom>
+          <a:noFill/>
+          <a:ln/>
+        </p:spPr>
+        <p:txBody>
+          <a:bodyPr wrap="square" lIns="0" tIns="0" rIns="0" bIns="0" rtlCol="0" anchor="ctr"/>
+          <a:lstStyle/>
+          <a:p>
+            <a:pPr algn="ctr" indent="0" marL="0">
+              <a:buNone/>
+            </a:pPr>
+            <a:r>
+              <a:rPr lang="en-US" sz="1400" b="1" dirty="0">
+                <a:solidFill>
+                  <a:srgbClr val="FFFFFF"/>
+                </a:solidFill>
+                <a:latin typeface="Courier New" pitchFamily="34" charset="0"/>
+                <a:ea typeface="Courier New" pitchFamily="34" charset="-122"/>
+                <a:cs typeface="Courier New" pitchFamily="34" charset="-120"/>
+              </a:rPr>
+              <a:t>F</a:t>
+            </a:r>
+            <a:endParaRPr lang="en-US" sz="1400" dirty="0"/>
+          </a:p>
+        </p:txBody>
+      </p:sp>
+      <p:sp>
+        <p:nvSpPr>
+          <p:cNvPr id="24" name="Text 22"/>
+          <p:cNvSpPr/>
+          <p:nvPr/>
+        </p:nvSpPr>
+        <p:spPr>
+          <a:xfrm>
+            <a:off x="960120" y="3721608"/>
+            <a:ext cx="3657600" cy="292608"/>
+          </a:xfrm>
+          <a:prstGeom prst="rect">
+            <a:avLst/>
+          </a:prstGeom>
+          <a:noFill/>
+          <a:ln/>
+        </p:spPr>
+        <p:txBody>
+          <a:bodyPr wrap="square" lIns="0" tIns="0" rIns="0" bIns="0" rtlCol="0" anchor="ctr"/>
+          <a:lstStyle/>
+          <a:p>
+            <a:pPr indent="0" marL="0">
+              <a:buNone/>
+            </a:pPr>
+            <a:r>
+              <a:rPr lang="en-US" sz="1300" b="1" dirty="0">
+                <a:solidFill>
+                  <a:srgbClr val="D97706"/>
+                </a:solidFill>
+                <a:latin typeface="Calibri" pitchFamily="34" charset="0"/>
+                <a:ea typeface="Calibri" pitchFamily="34" charset="-122"/>
+                <a:cs typeface="Calibri" pitchFamily="34" charset="-120"/>
+              </a:rPr>
+              <a:t>Fix file:// URLs</a:t>
+            </a:r>
+            <a:endParaRPr lang="en-US" sz="1300" dirty="0"/>
+          </a:p>
+        </p:txBody>
+      </p:sp>
+      <p:sp>
+        <p:nvSpPr>
+          <p:cNvPr id="25" name="Text 23"/>
+          <p:cNvSpPr/>
+          <p:nvPr/>
+        </p:nvSpPr>
+        <p:spPr>
+          <a:xfrm>
+            <a:off x="960120" y="4005072"/>
+            <a:ext cx="7589520" cy="256032"/>
+          </a:xfrm>
+          <a:prstGeom prst="rect">
+            <a:avLst/>
+          </a:prstGeom>
+          <a:noFill/>
+          <a:ln/>
+        </p:spPr>
+        <p:txBody>
+          <a:bodyPr wrap="square" lIns="0" tIns="0" rIns="0" bIns="0" rtlCol="0" anchor="ctr"/>
+          <a:lstStyle/>
+          <a:p>
+            <a:pPr indent="0" marL="0">
+              <a:buNone/>
+            </a:pPr>
+            <a:r>
+              <a:rPr lang="en-US" sz="1050" dirty="0">
+                <a:solidFill>
+                  <a:srgbClr val="5A5952"/>
+                </a:solidFill>
+                <a:latin typeface="Calibri" pitchFamily="34" charset="0"/>
+                <a:ea typeface="Calibri" pitchFamily="34" charset="-122"/>
+                <a:cs typeface="Calibri" pitchFamily="34" charset="-120"/>
+              </a:rPr>
+              <a:t>Broken local file:// paths are reconstructed as https:// using the hostname found in the path.</a:t>
+            </a:r>
+            <a:endParaRPr lang="en-US" sz="1050" dirty="0"/>
+          </a:p>
+        </p:txBody>
+      </p:sp>
+      <p:sp>
+        <p:nvSpPr>
+          <p:cNvPr id="26" name="Shape 24"/>
+          <p:cNvSpPr/>
+          <p:nvPr/>
+        </p:nvSpPr>
+        <p:spPr>
+          <a:xfrm>
+            <a:off x="960120" y="4279392"/>
+            <a:ext cx="3474720" cy="502920"/>
+          </a:xfrm>
+          <a:prstGeom prst="roundRect">
+            <a:avLst>
+              <a:gd name="adj" fmla="val 12727"/>
+            </a:avLst>
+          </a:prstGeom>
+          <a:solidFill>
+            <a:srgbClr val="1A1A18"/>
+          </a:solidFill>
+          <a:ln w="12700">
+            <a:solidFill>
+              <a:srgbClr val="1A1A18"/>
+            </a:solidFill>
+            <a:prstDash val="solid"/>
+          </a:ln>
+        </p:spPr>
+      </p:sp>
+      <p:sp>
+        <p:nvSpPr>
+          <p:cNvPr id="27" name="Text 25"/>
+          <p:cNvSpPr/>
+          <p:nvPr/>
+        </p:nvSpPr>
+        <p:spPr>
+          <a:xfrm>
+            <a:off x="1051560" y="4306824"/>
+            <a:ext cx="3291840" cy="438912"/>
+          </a:xfrm>
+          <a:prstGeom prst="rect">
+            <a:avLst/>
+          </a:prstGeom>
+          <a:noFill/>
+          <a:ln/>
+        </p:spPr>
+        <p:txBody>
+          <a:bodyPr wrap="square" lIns="0" tIns="0" rIns="0" bIns="0" rtlCol="0" anchor="ctr"/>
+          <a:lstStyle/>
+          <a:p>
+            <a:pPr indent="0" marL="0">
+              <a:buNone/>
+            </a:pPr>
+            <a:r>
+              <a:rPr lang="en-US" sz="800" dirty="0">
+                <a:solidFill>
+                  <a:srgbClr val="F87171"/>
+                </a:solidFill>
+                <a:latin typeface="Courier New" pitchFamily="34" charset="0"/>
+                <a:ea typeface="Courier New" pitchFamily="34" charset="-122"/>
+                <a:cs typeface="Courier New" pitchFamily="34" charset="-120"/>
+              </a:rPr>
+              <a:t>href="file://www.google.com/search"</a:t>
+            </a:r>
+            <a:endParaRPr lang="en-US" sz="800" dirty="0"/>
+          </a:p>
+        </p:txBody>
+      </p:sp>
+      <p:sp>
+        <p:nvSpPr>
+          <p:cNvPr id="28" name="Shape 26"/>
+          <p:cNvSpPr/>
+          <p:nvPr/>
+        </p:nvSpPr>
+        <p:spPr>
+          <a:xfrm>
+            <a:off x="4709160" y="4279392"/>
+            <a:ext cx="3886200" cy="502920"/>
+          </a:xfrm>
+          <a:prstGeom prst="roundRect">
+            <a:avLst>
+              <a:gd name="adj" fmla="val 12727"/>
+            </a:avLst>
+          </a:prstGeom>
+          <a:solidFill>
+            <a:srgbClr val="1A1A18"/>
+          </a:solidFill>
+          <a:ln w="12700">
+            <a:solidFill>
+              <a:srgbClr val="1A1A18"/>
+            </a:solidFill>
+            <a:prstDash val="solid"/>
+          </a:ln>
+        </p:spPr>
+      </p:sp>
+      <p:sp>
+        <p:nvSpPr>
+          <p:cNvPr id="29" name="Text 27"/>
+          <p:cNvSpPr/>
+          <p:nvPr/>
+        </p:nvSpPr>
+        <p:spPr>
+          <a:xfrm>
+            <a:off x="4800600" y="4306824"/>
+            <a:ext cx="3703320" cy="438912"/>
+          </a:xfrm>
+          <a:prstGeom prst="rect">
+            <a:avLst/>
+          </a:prstGeom>
+          <a:noFill/>
+          <a:ln/>
+        </p:spPr>
+        <p:txBody>
+          <a:bodyPr wrap="square" lIns="0" tIns="0" rIns="0" bIns="0" rtlCol="0" anchor="ctr"/>
+          <a:lstStyle/>
+          <a:p>
+            <a:pPr indent="0" marL="0">
+              <a:buNone/>
+            </a:pPr>
+            <a:r>
+              <a:rPr lang="en-US" sz="800" dirty="0">
+                <a:solidFill>
+                  <a:srgbClr val="A8D5A2"/>
+                </a:solidFill>
+                <a:latin typeface="Courier New" pitchFamily="34" charset="0"/>
+                <a:ea typeface="Courier New" pitchFamily="34" charset="-122"/>
+                <a:cs typeface="Courier New" pitchFamily="34" charset="-120"/>
+              </a:rPr>
+              <a:t>href="https://www.google.com/search"</a:t>
+            </a:r>
+            <a:endParaRPr lang="en-US" sz="800" dirty="0"/>
+          </a:p>
+        </p:txBody>
+      </p:sp>
+    </p:spTree>
+  </p:cSld>
+  <p:clrMapOvr>
+    <a:masterClrMapping/>
+  </p:clrMapOvr>
+</p:sld>
+</file>
+
+<file path=ppt/slides/slide8.xml><?xml version="1.0" encoding="utf-8"?>
+<p:sld xmlns:a="http://schemas.openxmlformats.org/drawingml/2006/main" xmlns:r="http://schemas.openxmlformats.org/officeDocument/2006/relationships" xmlns:p="http://schemas.openxmlformats.org/presentationml/2006/main">
+  <p:cSld name="Slide 8">
+    <p:bg>
+      <p:bgPr>
+        <a:solidFill>
+          <a:srgbClr val="FFFFFF"/>
+        </a:solidFill>
+      </p:bgPr>
+    </p:bg>
+    <p:spTree>
+      <p:nvGrpSpPr>
+        <p:cNvPr id="1" name=""/>
+        <p:cNvGrpSpPr/>
+        <p:nvPr/>
+      </p:nvGrpSpPr>
+      <p:grpSpPr>
+        <a:xfrm>
+          <a:off x="0" y="0"/>
+          <a:ext cx="0" cy="0"/>
+          <a:chOff x="0" y="0"/>
+          <a:chExt cx="0" cy="0"/>
+        </a:xfrm>
+      </p:grpSpPr>
+      <p:sp>
+        <p:nvSpPr>
+          <p:cNvPr id="2" name="Text 0"/>
+          <p:cNvSpPr/>
+          <p:nvPr/>
+        </p:nvSpPr>
+        <p:spPr>
+          <a:xfrm>
             <a:off x="457200" y="274320"/>
             <a:ext cx="8229600" cy="502920"/>
           </a:xfrm>
@@ -8828,7 +10419,7 @@
                 <a:ea typeface="Calibri" pitchFamily="34" charset="-122"/>
                 <a:cs typeface="Calibri" pitchFamily="34" charset="-120"/>
               </a:rPr>
-              <a:t>Converts Word documents to clean HTML, then our rules normalise the output.</a:t>
+              <a:t>Converts Word documents to clean HTML, then 14 rules normalise the output.</a:t>
             </a:r>
             <a:endParaRPr lang="en-US" sz="900" dirty="0"/>
           </a:p>
@@ -8979,7 +10570,7 @@
                 <a:ea typeface="Calibri" pitchFamily="34" charset="-122"/>
                 <a:cs typeface="Calibri" pitchFamily="34" charset="-120"/>
               </a:rPr>
-              <a:t>Reads .xlsx, .xls and .csv files. All sheets converted to HTML tables.</a:t>
+              <a:t>Reads .xlsx, .xls and .csv. All sheets converted to HTML tables.</a:t>
             </a:r>
             <a:endParaRPr lang="en-US" sz="900" dirty="0"/>
           </a:p>
@@ -9130,7 +10721,7 @@
                 <a:ea typeface="Calibri" pitchFamily="34" charset="-122"/>
                 <a:cs typeface="Calibri" pitchFamily="34" charset="-120"/>
               </a:rPr>
-              <a:t>Native browser API. sanitizeEditorHtml() normalises the output before rules run.</a:t>
+              <a:t>Native browser API. sanitizeEditorHtml() normalises output before rules run.</a:t>
             </a:r>
             <a:endParaRPr lang="en-US" sz="900" dirty="0"/>
           </a:p>
@@ -9583,7 +11174,7 @@
                 <a:ea typeface="Calibri" pitchFamily="34" charset="-122"/>
                 <a:cs typeface="Calibri" pitchFamily="34" charset="-120"/>
               </a:rPr>
-              <a:t>All libraries are bundled locally. Works fully offline once downloaded.</a:t>
+              <a:t>All libraries bundled locally. Works fully offline once downloaded.</a:t>
             </a:r>
             <a:endParaRPr lang="en-US" sz="900" dirty="0"/>
           </a:p>
@@ -9597,9 +11188,9 @@
 </p:sld>
 </file>
 
-<file path=ppt/slides/slide8.xml><?xml version="1.0" encoding="utf-8"?>
+<file path=ppt/slides/slide9.xml><?xml version="1.0" encoding="utf-8"?>
 <p:sld xmlns:a="http://schemas.openxmlformats.org/drawingml/2006/main" xmlns:r="http://schemas.openxmlformats.org/officeDocument/2006/relationships" xmlns:p="http://schemas.openxmlformats.org/presentationml/2006/main">
-  <p:cSld name="Slide 8">
+  <p:cSld name="Slide 9">
     <p:bg>
       <p:bgPr>
         <a:solidFill>
@@ -10191,7 +11782,7 @@
                   <a:srgbClr val="000000"/>
                 </a:solidFill>
               </a:rPr>
-              <a:t>🔗</a:t>
+              <a:t>🚫</a:t>
             </a:r>
             <a:endParaRPr lang="en-US" sz="1800" dirty="0"/>
           </a:p>
@@ -10230,7 +11821,7 @@
                 <a:ea typeface="Calibri" pitchFamily="34" charset="-122"/>
                 <a:cs typeface="Calibri" pitchFamily="34" charset="-120"/>
               </a:rPr>
-              <a:t>Phone links, fax excluded</a:t>
+              <a:t>Strikethrough text removed entirely</a:t>
             </a:r>
             <a:endParaRPr lang="en-US" sz="1000" dirty="0"/>
           </a:p>
@@ -10293,7 +11884,7 @@
                   <a:srgbClr val="000000"/>
                 </a:solidFill>
               </a:rPr>
-              <a:t>🚫</a:t>
+              <a:t>🔗</a:t>
             </a:r>
             <a:endParaRPr lang="en-US" sz="1800" dirty="0"/>
           </a:p>
@@ -10332,7 +11923,7 @@
                 <a:ea typeface="Calibri" pitchFamily="34" charset="-122"/>
                 <a:cs typeface="Calibri" pitchFamily="34" charset="-120"/>
               </a:rPr>
-              <a:t>No styles in output — pure HTML tags</a:t>
+              <a:t>strong wraps a · file:// URLs fixed</a:t>
             </a:r>
             <a:endParaRPr lang="en-US" sz="1000" dirty="0"/>
           </a:p>

</xml_diff>

<commit_message>
Updated POC & Demo Docs
Updated POC & Demo Docs
</commit_message>
<xml_diff>
--- a/dochtml-demo.pptx
+++ b/dochtml-demo.pptx
@@ -146,7 +146,7 @@
     </p:spTree>
     <p:extLst>
       <p:ext uri="{BB962C8B-B14F-4D97-AF65-F5344CB8AC3E}">
-        <p14:creationId xmlns:p14="http://schemas.microsoft.com/office/powerpoint/2010/main" val="1993953821"/>
+        <p14:creationId xmlns:p14="http://schemas.microsoft.com/office/powerpoint/2010/main" val="2552989394"/>
       </p:ext>
     </p:extLst>
   </p:cSld>
@@ -1875,6 +1875,13 @@
             <a:prstDash val="solid"/>
           </a:ln>
         </p:spPr>
+        <p:txBody>
+          <a:bodyPr/>
+          <a:lstStyle/>
+          <a:p>
+            <a:endParaRPr/>
+          </a:p>
+        </p:txBody>
       </p:sp>
       <p:sp>
         <p:nvSpPr>
@@ -1977,6 +1984,13 @@
             <a:prstDash val="solid"/>
           </a:ln>
         </p:spPr>
+        <p:txBody>
+          <a:bodyPr/>
+          <a:lstStyle/>
+          <a:p>
+            <a:endParaRPr/>
+          </a:p>
+        </p:txBody>
       </p:sp>
       <p:sp>
         <p:nvSpPr>
@@ -2079,6 +2093,13 @@
             <a:prstDash val="solid"/>
           </a:ln>
         </p:spPr>
+        <p:txBody>
+          <a:bodyPr/>
+          <a:lstStyle/>
+          <a:p>
+            <a:endParaRPr/>
+          </a:p>
+        </p:txBody>
       </p:sp>
       <p:sp>
         <p:nvSpPr>
@@ -2181,6 +2202,13 @@
             <a:prstDash val="solid"/>
           </a:ln>
         </p:spPr>
+        <p:txBody>
+          <a:bodyPr/>
+          <a:lstStyle/>
+          <a:p>
+            <a:endParaRPr/>
+          </a:p>
+        </p:txBody>
       </p:sp>
       <p:sp>
         <p:nvSpPr>
@@ -2283,6 +2311,13 @@
             <a:prstDash val="solid"/>
           </a:ln>
         </p:spPr>
+        <p:txBody>
+          <a:bodyPr/>
+          <a:lstStyle/>
+          <a:p>
+            <a:endParaRPr/>
+          </a:p>
+        </p:txBody>
       </p:sp>
       <p:sp>
         <p:nvSpPr>
@@ -2385,6 +2420,13 @@
             <a:prstDash val="solid"/>
           </a:ln>
         </p:spPr>
+        <p:txBody>
+          <a:bodyPr/>
+          <a:lstStyle/>
+          <a:p>
+            <a:endParaRPr/>
+          </a:p>
+        </p:txBody>
       </p:sp>
       <p:sp>
         <p:nvSpPr>
@@ -2614,7 +2656,7 @@
                 </a:solidFill>
                 <a:latin typeface="Calibri"/>
               </a:rPr>
-              <a:t>21 automated checks · line-numbered test report</a:t>
+              <a:t>22 automated checks · line-numbered test report</a:t>
             </a:r>
           </a:p>
         </p:txBody>
@@ -4996,7 +5038,7 @@
                 <a:ea typeface="Calibri" pitchFamily="34" charset="-122"/>
                 <a:cs typeface="Calibri" pitchFamily="34" charset="-120"/>
               </a:rPr>
-              <a:t>14 Conversion Rules</a:t>
+              <a:t>15 Conversion Rules</a:t>
             </a:r>
             <a:endParaRPr lang="en-US" sz="2600" dirty="0"/>
           </a:p>
@@ -5074,6 +5116,13 @@
             </a:outerShdw>
           </a:effectLst>
         </p:spPr>
+        <p:txBody>
+          <a:bodyPr/>
+          <a:lstStyle/>
+          <a:p>
+            <a:endParaRPr/>
+          </a:p>
+        </p:txBody>
       </p:sp>
       <p:sp>
         <p:nvSpPr>
@@ -5101,6 +5150,13 @@
             <a:prstDash val="solid"/>
           </a:ln>
         </p:spPr>
+        <p:txBody>
+          <a:bodyPr/>
+          <a:lstStyle/>
+          <a:p>
+            <a:endParaRPr/>
+          </a:p>
+        </p:txBody>
       </p:sp>
       <p:sp>
         <p:nvSpPr>
@@ -5227,7 +5283,7 @@
         </p:nvSpPr>
         <p:spPr>
           <a:xfrm>
-            <a:off x="365760" y="1682496"/>
+            <a:off x="365760" y="1591056"/>
             <a:ext cx="4023360" cy="493776"/>
           </a:xfrm>
           <a:prstGeom prst="roundRect">
@@ -5252,6 +5308,13 @@
             </a:outerShdw>
           </a:effectLst>
         </p:spPr>
+        <p:txBody>
+          <a:bodyPr/>
+          <a:lstStyle/>
+          <a:p>
+            <a:endParaRPr/>
+          </a:p>
+        </p:txBody>
       </p:sp>
       <p:sp>
         <p:nvSpPr>
@@ -5261,7 +5324,7 @@
         </p:nvSpPr>
         <p:spPr>
           <a:xfrm>
-            <a:off x="365760" y="1682496"/>
+            <a:off x="365760" y="1591056"/>
             <a:ext cx="347472" cy="493776"/>
           </a:xfrm>
           <a:prstGeom prst="roundRect">
@@ -5279,6 +5342,13 @@
             <a:prstDash val="solid"/>
           </a:ln>
         </p:spPr>
+        <p:txBody>
+          <a:bodyPr/>
+          <a:lstStyle/>
+          <a:p>
+            <a:endParaRPr/>
+          </a:p>
+        </p:txBody>
       </p:sp>
       <p:sp>
         <p:nvSpPr>
@@ -5288,7 +5358,7 @@
         </p:nvSpPr>
         <p:spPr>
           <a:xfrm>
-            <a:off x="365760" y="1682496"/>
+            <a:off x="365760" y="1591056"/>
             <a:ext cx="347472" cy="493776"/>
           </a:xfrm>
           <a:prstGeom prst="rect">
@@ -5327,7 +5397,7 @@
         </p:nvSpPr>
         <p:spPr>
           <a:xfrm>
-            <a:off x="786384" y="1709928"/>
+            <a:off x="786384" y="1618488"/>
             <a:ext cx="2286000" cy="228600"/>
           </a:xfrm>
           <a:prstGeom prst="rect">
@@ -5366,7 +5436,7 @@
         </p:nvSpPr>
         <p:spPr>
           <a:xfrm>
-            <a:off x="786384" y="1938528"/>
+            <a:off x="786384" y="1847088"/>
             <a:ext cx="3474720" cy="201168"/>
           </a:xfrm>
           <a:prstGeom prst="rect">
@@ -5405,7 +5475,7 @@
         </p:nvSpPr>
         <p:spPr>
           <a:xfrm>
-            <a:off x="365760" y="2249424"/>
+            <a:off x="365760" y="2066543"/>
             <a:ext cx="4023360" cy="493776"/>
           </a:xfrm>
           <a:prstGeom prst="roundRect">
@@ -5430,6 +5500,13 @@
             </a:outerShdw>
           </a:effectLst>
         </p:spPr>
+        <p:txBody>
+          <a:bodyPr/>
+          <a:lstStyle/>
+          <a:p>
+            <a:endParaRPr/>
+          </a:p>
+        </p:txBody>
       </p:sp>
       <p:sp>
         <p:nvSpPr>
@@ -5439,7 +5516,7 @@
         </p:nvSpPr>
         <p:spPr>
           <a:xfrm>
-            <a:off x="365760" y="2249424"/>
+            <a:off x="365760" y="2066543"/>
             <a:ext cx="347472" cy="493776"/>
           </a:xfrm>
           <a:prstGeom prst="roundRect">
@@ -5457,6 +5534,13 @@
             <a:prstDash val="solid"/>
           </a:ln>
         </p:spPr>
+        <p:txBody>
+          <a:bodyPr/>
+          <a:lstStyle/>
+          <a:p>
+            <a:endParaRPr/>
+          </a:p>
+        </p:txBody>
       </p:sp>
       <p:sp>
         <p:nvSpPr>
@@ -5466,7 +5550,7 @@
         </p:nvSpPr>
         <p:spPr>
           <a:xfrm>
-            <a:off x="365760" y="2249424"/>
+            <a:off x="365760" y="2066543"/>
             <a:ext cx="347472" cy="493776"/>
           </a:xfrm>
           <a:prstGeom prst="rect">
@@ -5505,7 +5589,7 @@
         </p:nvSpPr>
         <p:spPr>
           <a:xfrm>
-            <a:off x="786384" y="2276856"/>
+            <a:off x="786384" y="2093976"/>
             <a:ext cx="2286000" cy="228600"/>
           </a:xfrm>
           <a:prstGeom prst="rect">
@@ -5544,7 +5628,7 @@
         </p:nvSpPr>
         <p:spPr>
           <a:xfrm>
-            <a:off x="786384" y="2505456"/>
+            <a:off x="786384" y="2322576"/>
             <a:ext cx="3474720" cy="201168"/>
           </a:xfrm>
           <a:prstGeom prst="rect">
@@ -5583,7 +5667,7 @@
         </p:nvSpPr>
         <p:spPr>
           <a:xfrm>
-            <a:off x="365760" y="2816352"/>
+            <a:off x="365760" y="2542032"/>
             <a:ext cx="4023360" cy="493776"/>
           </a:xfrm>
           <a:prstGeom prst="roundRect">
@@ -5608,6 +5692,13 @@
             </a:outerShdw>
           </a:effectLst>
         </p:spPr>
+        <p:txBody>
+          <a:bodyPr/>
+          <a:lstStyle/>
+          <a:p>
+            <a:endParaRPr/>
+          </a:p>
+        </p:txBody>
       </p:sp>
       <p:sp>
         <p:nvSpPr>
@@ -5617,7 +5708,7 @@
         </p:nvSpPr>
         <p:spPr>
           <a:xfrm>
-            <a:off x="365760" y="2816352"/>
+            <a:off x="365760" y="2542032"/>
             <a:ext cx="347472" cy="493776"/>
           </a:xfrm>
           <a:prstGeom prst="roundRect">
@@ -5635,6 +5726,13 @@
             <a:prstDash val="solid"/>
           </a:ln>
         </p:spPr>
+        <p:txBody>
+          <a:bodyPr/>
+          <a:lstStyle/>
+          <a:p>
+            <a:endParaRPr/>
+          </a:p>
+        </p:txBody>
       </p:sp>
       <p:sp>
         <p:nvSpPr>
@@ -5644,7 +5742,7 @@
         </p:nvSpPr>
         <p:spPr>
           <a:xfrm>
-            <a:off x="365760" y="2816352"/>
+            <a:off x="365760" y="2542032"/>
             <a:ext cx="347472" cy="493776"/>
           </a:xfrm>
           <a:prstGeom prst="rect">
@@ -5683,7 +5781,7 @@
         </p:nvSpPr>
         <p:spPr>
           <a:xfrm>
-            <a:off x="786384" y="2843784"/>
+            <a:off x="786384" y="2569463"/>
             <a:ext cx="2286000" cy="228600"/>
           </a:xfrm>
           <a:prstGeom prst="rect">
@@ -5722,7 +5820,7 @@
         </p:nvSpPr>
         <p:spPr>
           <a:xfrm>
-            <a:off x="786384" y="3072384"/>
+            <a:off x="786384" y="2798063"/>
             <a:ext cx="3474720" cy="201168"/>
           </a:xfrm>
           <a:prstGeom prst="rect">
@@ -5761,7 +5859,7 @@
         </p:nvSpPr>
         <p:spPr>
           <a:xfrm>
-            <a:off x="365760" y="3383280"/>
+            <a:off x="365760" y="3017520"/>
             <a:ext cx="4023360" cy="493776"/>
           </a:xfrm>
           <a:prstGeom prst="roundRect">
@@ -5786,6 +5884,13 @@
             </a:outerShdw>
           </a:effectLst>
         </p:spPr>
+        <p:txBody>
+          <a:bodyPr/>
+          <a:lstStyle/>
+          <a:p>
+            <a:endParaRPr/>
+          </a:p>
+        </p:txBody>
       </p:sp>
       <p:sp>
         <p:nvSpPr>
@@ -5795,7 +5900,7 @@
         </p:nvSpPr>
         <p:spPr>
           <a:xfrm>
-            <a:off x="365760" y="3383280"/>
+            <a:off x="365760" y="3017520"/>
             <a:ext cx="347472" cy="493776"/>
           </a:xfrm>
           <a:prstGeom prst="roundRect">
@@ -5813,6 +5918,13 @@
             <a:prstDash val="solid"/>
           </a:ln>
         </p:spPr>
+        <p:txBody>
+          <a:bodyPr/>
+          <a:lstStyle/>
+          <a:p>
+            <a:endParaRPr/>
+          </a:p>
+        </p:txBody>
       </p:sp>
       <p:sp>
         <p:nvSpPr>
@@ -5822,7 +5934,7 @@
         </p:nvSpPr>
         <p:spPr>
           <a:xfrm>
-            <a:off x="365760" y="3383280"/>
+            <a:off x="365760" y="3017520"/>
             <a:ext cx="347472" cy="493776"/>
           </a:xfrm>
           <a:prstGeom prst="rect">
@@ -5861,7 +5973,7 @@
         </p:nvSpPr>
         <p:spPr>
           <a:xfrm>
-            <a:off x="786384" y="3410712"/>
+            <a:off x="786384" y="3044951"/>
             <a:ext cx="2286000" cy="228600"/>
           </a:xfrm>
           <a:prstGeom prst="rect">
@@ -5900,7 +6012,7 @@
         </p:nvSpPr>
         <p:spPr>
           <a:xfrm>
-            <a:off x="786384" y="3639312"/>
+            <a:off x="786384" y="3273551"/>
             <a:ext cx="3474720" cy="201168"/>
           </a:xfrm>
           <a:prstGeom prst="rect">
@@ -5939,7 +6051,7 @@
         </p:nvSpPr>
         <p:spPr>
           <a:xfrm>
-            <a:off x="365760" y="3950208"/>
+            <a:off x="365760" y="3493008"/>
             <a:ext cx="4023360" cy="493776"/>
           </a:xfrm>
           <a:prstGeom prst="roundRect">
@@ -5964,6 +6076,13 @@
             </a:outerShdw>
           </a:effectLst>
         </p:spPr>
+        <p:txBody>
+          <a:bodyPr/>
+          <a:lstStyle/>
+          <a:p>
+            <a:endParaRPr/>
+          </a:p>
+        </p:txBody>
       </p:sp>
       <p:sp>
         <p:nvSpPr>
@@ -5973,7 +6092,7 @@
         </p:nvSpPr>
         <p:spPr>
           <a:xfrm>
-            <a:off x="365760" y="3950208"/>
+            <a:off x="365760" y="3493008"/>
             <a:ext cx="347472" cy="493776"/>
           </a:xfrm>
           <a:prstGeom prst="roundRect">
@@ -5991,6 +6110,13 @@
             <a:prstDash val="solid"/>
           </a:ln>
         </p:spPr>
+        <p:txBody>
+          <a:bodyPr/>
+          <a:lstStyle/>
+          <a:p>
+            <a:endParaRPr/>
+          </a:p>
+        </p:txBody>
       </p:sp>
       <p:sp>
         <p:nvSpPr>
@@ -6000,7 +6126,7 @@
         </p:nvSpPr>
         <p:spPr>
           <a:xfrm>
-            <a:off x="365760" y="3950208"/>
+            <a:off x="365760" y="3493008"/>
             <a:ext cx="347472" cy="493776"/>
           </a:xfrm>
           <a:prstGeom prst="rect">
@@ -6039,7 +6165,7 @@
         </p:nvSpPr>
         <p:spPr>
           <a:xfrm>
-            <a:off x="786384" y="3977640"/>
+            <a:off x="786384" y="3520439"/>
             <a:ext cx="2286000" cy="228600"/>
           </a:xfrm>
           <a:prstGeom prst="rect">
@@ -6078,7 +6204,7 @@
         </p:nvSpPr>
         <p:spPr>
           <a:xfrm>
-            <a:off x="786384" y="4206240"/>
+            <a:off x="786384" y="3749039"/>
             <a:ext cx="3474720" cy="201168"/>
           </a:xfrm>
           <a:prstGeom prst="rect">
@@ -6142,6 +6268,13 @@
             </a:outerShdw>
           </a:effectLst>
         </p:spPr>
+        <p:txBody>
+          <a:bodyPr/>
+          <a:lstStyle/>
+          <a:p>
+            <a:endParaRPr/>
+          </a:p>
+        </p:txBody>
       </p:sp>
       <p:sp>
         <p:nvSpPr>
@@ -6169,6 +6302,13 @@
             <a:prstDash val="solid"/>
           </a:ln>
         </p:spPr>
+        <p:txBody>
+          <a:bodyPr/>
+          <a:lstStyle/>
+          <a:p>
+            <a:endParaRPr/>
+          </a:p>
+        </p:txBody>
       </p:sp>
       <p:sp>
         <p:nvSpPr>
@@ -6320,6 +6460,13 @@
             </a:outerShdw>
           </a:effectLst>
         </p:spPr>
+        <p:txBody>
+          <a:bodyPr/>
+          <a:lstStyle/>
+          <a:p>
+            <a:endParaRPr/>
+          </a:p>
+        </p:txBody>
       </p:sp>
       <p:sp>
         <p:nvSpPr>
@@ -6347,6 +6494,13 @@
             <a:prstDash val="solid"/>
           </a:ln>
         </p:spPr>
+        <p:txBody>
+          <a:bodyPr/>
+          <a:lstStyle/>
+          <a:p>
+            <a:endParaRPr/>
+          </a:p>
+        </p:txBody>
       </p:sp>
       <p:sp>
         <p:nvSpPr>
@@ -6498,6 +6652,13 @@
             </a:outerShdw>
           </a:effectLst>
         </p:spPr>
+        <p:txBody>
+          <a:bodyPr/>
+          <a:lstStyle/>
+          <a:p>
+            <a:endParaRPr/>
+          </a:p>
+        </p:txBody>
       </p:sp>
       <p:sp>
         <p:nvSpPr>
@@ -6525,6 +6686,13 @@
             <a:prstDash val="solid"/>
           </a:ln>
         </p:spPr>
+        <p:txBody>
+          <a:bodyPr/>
+          <a:lstStyle/>
+          <a:p>
+            <a:endParaRPr/>
+          </a:p>
+        </p:txBody>
       </p:sp>
       <p:sp>
         <p:nvSpPr>
@@ -6676,6 +6844,13 @@
             </a:outerShdw>
           </a:effectLst>
         </p:spPr>
+        <p:txBody>
+          <a:bodyPr/>
+          <a:lstStyle/>
+          <a:p>
+            <a:endParaRPr/>
+          </a:p>
+        </p:txBody>
       </p:sp>
       <p:sp>
         <p:nvSpPr>
@@ -6703,6 +6878,13 @@
             <a:prstDash val="solid"/>
           </a:ln>
         </p:spPr>
+        <p:txBody>
+          <a:bodyPr/>
+          <a:lstStyle/>
+          <a:p>
+            <a:endParaRPr/>
+          </a:p>
+        </p:txBody>
       </p:sp>
       <p:sp>
         <p:nvSpPr>
@@ -6854,6 +7036,13 @@
             </a:outerShdw>
           </a:effectLst>
         </p:spPr>
+        <p:txBody>
+          <a:bodyPr/>
+          <a:lstStyle/>
+          <a:p>
+            <a:endParaRPr/>
+          </a:p>
+        </p:txBody>
       </p:sp>
       <p:sp>
         <p:nvSpPr>
@@ -6881,6 +7070,13 @@
             <a:prstDash val="solid"/>
           </a:ln>
         </p:spPr>
+        <p:txBody>
+          <a:bodyPr/>
+          <a:lstStyle/>
+          <a:p>
+            <a:endParaRPr/>
+          </a:p>
+        </p:txBody>
       </p:sp>
       <p:sp>
         <p:nvSpPr>
@@ -7032,6 +7228,13 @@
             </a:outerShdw>
           </a:effectLst>
         </p:spPr>
+        <p:txBody>
+          <a:bodyPr/>
+          <a:lstStyle/>
+          <a:p>
+            <a:endParaRPr/>
+          </a:p>
+        </p:txBody>
       </p:sp>
       <p:sp>
         <p:nvSpPr>
@@ -7059,6 +7262,13 @@
             <a:prstDash val="solid"/>
           </a:ln>
         </p:spPr>
+        <p:txBody>
+          <a:bodyPr/>
+          <a:lstStyle/>
+          <a:p>
+            <a:endParaRPr/>
+          </a:p>
+        </p:txBody>
       </p:sp>
       <p:sp>
         <p:nvSpPr>
@@ -7203,6 +7413,13 @@
             <a:prstDash val="solid"/>
           </a:ln>
         </p:spPr>
+        <p:txBody>
+          <a:bodyPr/>
+          <a:lstStyle/>
+          <a:p>
+            <a:endParaRPr/>
+          </a:p>
+        </p:txBody>
       </p:sp>
       <p:sp>
         <p:nvSpPr>
@@ -7237,7 +7454,199 @@
                 <a:ea typeface="Courier New" pitchFamily="34" charset="-122"/>
                 <a:cs typeface="Courier New" pitchFamily="34" charset="-120"/>
               </a:rPr>
-              <a:t>Rule E — &lt;strong&gt; wraps &lt;a&gt;    |    Rule C — Adjacent/nested &lt;strong&gt; merged    |    Rule F — file:// URLs fixed to https://</a:t>
+              <a:t>Rule E — strong wraps a  |  Rule C — adjacent/nested strong merged  |  Rule F — file:// fixed  |  Rule G — unclosed quotes/tags auto-fixed</a:t>
+            </a:r>
+            <a:endParaRPr lang="en-US" sz="850" dirty="0"/>
+          </a:p>
+        </p:txBody>
+      </p:sp>
+      <p:sp>
+        <p:nvSpPr>
+          <p:cNvPr id="66" name="Shape 57"/>
+          <p:cNvSpPr/>
+          <p:nvPr/>
+        </p:nvSpPr>
+        <p:spPr>
+          <a:xfrm>
+            <a:off x="365760" y="3986784"/>
+            <a:ext cx="4023360" cy="493776"/>
+          </a:xfrm>
+          <a:prstGeom prst="roundRect">
+            <a:avLst>
+              <a:gd name="adj" fmla="val 14815"/>
+            </a:avLst>
+          </a:prstGeom>
+          <a:solidFill>
+            <a:srgbClr val="FFFFFF"/>
+          </a:solidFill>
+          <a:ln w="12700">
+            <a:solidFill>
+              <a:srgbClr val="E2E0D8"/>
+            </a:solidFill>
+            <a:prstDash val="solid"/>
+          </a:ln>
+          <a:effectLst>
+            <a:outerShdw blurRad="101600" dist="38100" dir="2700000" algn="bl" rotWithShape="0">
+              <a:srgbClr val="000000">
+                <a:alpha val="10000"/>
+              </a:srgbClr>
+            </a:outerShdw>
+          </a:effectLst>
+        </p:spPr>
+        <p:txBody>
+          <a:bodyPr/>
+          <a:lstStyle/>
+          <a:p>
+            <a:endParaRPr/>
+          </a:p>
+        </p:txBody>
+      </p:sp>
+      <p:sp>
+        <p:nvSpPr>
+          <p:cNvPr id="67" name="Shape 58"/>
+          <p:cNvSpPr/>
+          <p:nvPr/>
+        </p:nvSpPr>
+        <p:spPr>
+          <a:xfrm>
+            <a:off x="365760" y="3986784"/>
+            <a:ext cx="347472" cy="493776"/>
+          </a:xfrm>
+          <a:prstGeom prst="roundRect">
+            <a:avLst>
+              <a:gd name="adj" fmla="val 21053"/>
+            </a:avLst>
+          </a:prstGeom>
+          <a:solidFill>
+            <a:srgbClr val="7C4DAB"/>
+          </a:solidFill>
+          <a:ln w="12700">
+            <a:solidFill>
+              <a:srgbClr val="9B2C2C"/>
+            </a:solidFill>
+            <a:prstDash val="solid"/>
+          </a:ln>
+        </p:spPr>
+        <p:txBody>
+          <a:bodyPr/>
+          <a:lstStyle/>
+          <a:p>
+            <a:endParaRPr/>
+          </a:p>
+        </p:txBody>
+      </p:sp>
+      <p:sp>
+        <p:nvSpPr>
+          <p:cNvPr id="68" name="Text 59"/>
+          <p:cNvSpPr/>
+          <p:nvPr/>
+        </p:nvSpPr>
+        <p:spPr>
+          <a:xfrm>
+            <a:off x="365760" y="3986784"/>
+            <a:ext cx="347472" cy="493776"/>
+          </a:xfrm>
+          <a:prstGeom prst="rect">
+            <a:avLst/>
+          </a:prstGeom>
+          <a:noFill/>
+          <a:ln/>
+        </p:spPr>
+        <p:txBody>
+          <a:bodyPr wrap="square" lIns="0" tIns="0" rIns="0" bIns="0" rtlCol="0" anchor="ctr"/>
+          <a:lstStyle/>
+          <a:p>
+            <a:pPr marL="0" indent="0" algn="ctr">
+              <a:buNone/>
+            </a:pPr>
+            <a:r>
+              <a:rPr lang="en-US" sz="800" b="1" dirty="0">
+                <a:solidFill>
+                  <a:srgbClr val="FFFFFF"/>
+                </a:solidFill>
+                <a:latin typeface="Courier New" pitchFamily="34" charset="0"/>
+                <a:ea typeface="Courier New" pitchFamily="34" charset="-122"/>
+                <a:cs typeface="Courier New" pitchFamily="34" charset="-120"/>
+              </a:rPr>
+              <a:t>G</a:t>
+            </a:r>
+            <a:endParaRPr lang="en-US" sz="800" dirty="0"/>
+          </a:p>
+        </p:txBody>
+      </p:sp>
+      <p:sp>
+        <p:nvSpPr>
+          <p:cNvPr id="69" name="Text 60"/>
+          <p:cNvSpPr/>
+          <p:nvPr/>
+        </p:nvSpPr>
+        <p:spPr>
+          <a:xfrm>
+            <a:off x="786384" y="4014215"/>
+            <a:ext cx="2286000" cy="228600"/>
+          </a:xfrm>
+          <a:prstGeom prst="rect">
+            <a:avLst/>
+          </a:prstGeom>
+          <a:noFill/>
+          <a:ln/>
+        </p:spPr>
+        <p:txBody>
+          <a:bodyPr wrap="square" lIns="0" tIns="0" rIns="0" bIns="0" rtlCol="0" anchor="ctr"/>
+          <a:lstStyle/>
+          <a:p>
+            <a:pPr marL="0" indent="0">
+              <a:buNone/>
+            </a:pPr>
+            <a:r>
+              <a:rPr lang="en-US" sz="1000" b="1" dirty="0">
+                <a:solidFill>
+                  <a:srgbClr val="1A1A18"/>
+                </a:solidFill>
+                <a:latin typeface="Calibri" pitchFamily="34" charset="0"/>
+                <a:ea typeface="Calibri" pitchFamily="34" charset="-122"/>
+                <a:cs typeface="Calibri" pitchFamily="34" charset="-120"/>
+              </a:rPr>
+              <a:t>Fix syntax errors</a:t>
+            </a:r>
+            <a:endParaRPr lang="en-US" sz="1000" dirty="0"/>
+          </a:p>
+        </p:txBody>
+      </p:sp>
+      <p:sp>
+        <p:nvSpPr>
+          <p:cNvPr id="70" name="Text 61"/>
+          <p:cNvSpPr/>
+          <p:nvPr/>
+        </p:nvSpPr>
+        <p:spPr>
+          <a:xfrm>
+            <a:off x="786384" y="4242816"/>
+            <a:ext cx="3474720" cy="201168"/>
+          </a:xfrm>
+          <a:prstGeom prst="rect">
+            <a:avLst/>
+          </a:prstGeom>
+          <a:noFill/>
+          <a:ln/>
+        </p:spPr>
+        <p:txBody>
+          <a:bodyPr wrap="square" lIns="0" tIns="0" rIns="0" bIns="0" rtlCol="0" anchor="ctr"/>
+          <a:lstStyle/>
+          <a:p>
+            <a:pPr marL="0" indent="0">
+              <a:buNone/>
+            </a:pPr>
+            <a:r>
+              <a:rPr lang="en-US" sz="850" dirty="0">
+                <a:solidFill>
+                  <a:srgbClr val="5A5952"/>
+                </a:solidFill>
+                <a:latin typeface="Courier New" pitchFamily="34" charset="0"/>
+                <a:ea typeface="Courier New" pitchFamily="34" charset="-122"/>
+                <a:cs typeface="Courier New" pitchFamily="34" charset="-120"/>
+              </a:rPr>
+              <a:t>Unclosed quotes/tags auto-fixed</a:t>
             </a:r>
             <a:endParaRPr lang="en-US" sz="850" dirty="0"/>
           </a:p>

</xml_diff>